<commit_message>
aula 15  e 16
</commit_message>
<xml_diff>
--- a/Conteudo Aulas/aula_interacao_js_html.pptx
+++ b/Conteudo Aulas/aula_interacao_js_html.pptx
@@ -5,15 +5,20 @@
     <p:sldMasterId id="2147483648" r:id="rId1"/>
   </p:sldMasterIdLst>
   <p:sldIdLst>
-    <p:sldId id="256" r:id="rId7"/>
-    <p:sldId id="257" r:id="rId8"/>
-    <p:sldId id="258" r:id="rId9"/>
-    <p:sldId id="259" r:id="rId10"/>
-    <p:sldId id="260" r:id="rId11"/>
-    <p:sldId id="261" r:id="rId12"/>
-    <p:sldId id="262" r:id="rId13"/>
+    <p:sldId id="256" r:id="rId2"/>
+    <p:sldId id="257" r:id="rId3"/>
+    <p:sldId id="258" r:id="rId4"/>
+    <p:sldId id="259" r:id="rId5"/>
+    <p:sldId id="260" r:id="rId6"/>
+    <p:sldId id="261" r:id="rId7"/>
+    <p:sldId id="262" r:id="rId8"/>
+    <p:sldId id="263" r:id="rId9"/>
+    <p:sldId id="264" r:id="rId10"/>
+    <p:sldId id="265" r:id="rId11"/>
+    <p:sldId id="266" r:id="rId12"/>
+    <p:sldId id="267" r:id="rId13"/>
   </p:sldIdLst>
-  <p:sldSz cx="12191695" cy="6858000" type="screen4x3"/>
+  <p:sldSz cx="12192000" cy="6858000"/>
   <p:notesSz cx="6858000" cy="9144000"/>
   <p:defaultTextStyle>
     <a:defPPr>
@@ -110,6 +115,22 @@
       </a:defRPr>
     </a:lvl9pPr>
   </p:defaultTextStyle>
+  <p:extLst>
+    <p:ext uri="{EFAFB233-063F-42B5-8137-9DF3F51BA10A}">
+      <p15:sldGuideLst xmlns:p15="http://schemas.microsoft.com/office/powerpoint/2012/main">
+        <p15:guide id="1" orient="horz" pos="2160">
+          <p15:clr>
+            <a:srgbClr val="A4A3A4"/>
+          </p15:clr>
+        </p15:guide>
+        <p15:guide id="2" pos="2880">
+          <p15:clr>
+            <a:srgbClr val="A4A3A4"/>
+          </p15:clr>
+        </p15:guide>
+      </p15:sldGuideLst>
+    </p:ext>
+  </p:extLst>
 </p:presentation>
 </file>
 
@@ -151,10 +172,9 @@
           <a:lstStyle/>
           <a:p>
             <a:r>
-              <a:rPr lang="en-US" smtClean="0"/>
+              <a:rPr lang="en-US"/>
               <a:t>Click to edit Master title style</a:t>
             </a:r>
-            <a:endParaRPr lang="en-US"/>
           </a:p>
         </p:txBody>
       </p:sp>
@@ -270,10 +290,9 @@
           </a:lstStyle>
           <a:p>
             <a:r>
-              <a:rPr lang="en-US" smtClean="0"/>
+              <a:rPr lang="en-US"/>
               <a:t>Click to edit Master subtitle style</a:t>
             </a:r>
-            <a:endParaRPr lang="en-US"/>
           </a:p>
         </p:txBody>
       </p:sp>
@@ -294,7 +313,7 @@
           <a:p>
             <a:fld id="{5BCAD085-E8A6-8845-BD4E-CB4CCA059FC4}" type="datetimeFigureOut">
               <a:rPr lang="en-US" smtClean="0"/>
-              <a:t>1/27/13</a:t>
+              <a:t>9/18/2026</a:t>
             </a:fld>
             <a:endParaRPr lang="en-US"/>
           </a:p>
@@ -336,7 +355,7 @@
           <a:p>
             <a:fld id="{C1FF6DA9-008F-8B48-92A6-B652298478BF}" type="slidenum">
               <a:rPr lang="en-US" smtClean="0"/>
-              <a:t>‹#›</a:t>
+              <a:t>‹nº›</a:t>
             </a:fld>
             <a:endParaRPr lang="en-US"/>
           </a:p>
@@ -388,10 +407,9 @@
           <a:lstStyle/>
           <a:p>
             <a:r>
-              <a:rPr lang="en-US" smtClean="0"/>
+              <a:rPr lang="en-US"/>
               <a:t>Click to edit Master title style</a:t>
             </a:r>
-            <a:endParaRPr lang="en-US"/>
           </a:p>
         </p:txBody>
       </p:sp>
@@ -412,38 +430,37 @@
           <a:p>
             <a:pPr lvl="0"/>
             <a:r>
-              <a:rPr lang="en-US" smtClean="0"/>
+              <a:rPr lang="en-US"/>
               <a:t>Click to edit Master text styles</a:t>
             </a:r>
           </a:p>
           <a:p>
             <a:pPr lvl="1"/>
             <a:r>
-              <a:rPr lang="en-US" smtClean="0"/>
+              <a:rPr lang="en-US"/>
               <a:t>Second level</a:t>
             </a:r>
           </a:p>
           <a:p>
             <a:pPr lvl="2"/>
             <a:r>
-              <a:rPr lang="en-US" smtClean="0"/>
+              <a:rPr lang="en-US"/>
               <a:t>Third level</a:t>
             </a:r>
           </a:p>
           <a:p>
             <a:pPr lvl="3"/>
             <a:r>
-              <a:rPr lang="en-US" smtClean="0"/>
+              <a:rPr lang="en-US"/>
               <a:t>Fourth level</a:t>
             </a:r>
           </a:p>
           <a:p>
             <a:pPr lvl="4"/>
             <a:r>
-              <a:rPr lang="en-US" smtClean="0"/>
+              <a:rPr lang="en-US"/>
               <a:t>Fifth level</a:t>
             </a:r>
-            <a:endParaRPr lang="en-US"/>
           </a:p>
         </p:txBody>
       </p:sp>
@@ -464,7 +481,7 @@
           <a:p>
             <a:fld id="{5BCAD085-E8A6-8845-BD4E-CB4CCA059FC4}" type="datetimeFigureOut">
               <a:rPr lang="en-US" smtClean="0"/>
-              <a:t>1/27/13</a:t>
+              <a:t>9/18/2026</a:t>
             </a:fld>
             <a:endParaRPr lang="en-US"/>
           </a:p>
@@ -506,7 +523,7 @@
           <a:p>
             <a:fld id="{C1FF6DA9-008F-8B48-92A6-B652298478BF}" type="slidenum">
               <a:rPr lang="en-US" smtClean="0"/>
-              <a:t>‹#›</a:t>
+              <a:t>‹nº›</a:t>
             </a:fld>
             <a:endParaRPr lang="en-US"/>
           </a:p>
@@ -563,10 +580,9 @@
           <a:lstStyle/>
           <a:p>
             <a:r>
-              <a:rPr lang="en-US" smtClean="0"/>
+              <a:rPr lang="en-US"/>
               <a:t>Click to edit Master title style</a:t>
             </a:r>
-            <a:endParaRPr lang="en-US"/>
           </a:p>
         </p:txBody>
       </p:sp>
@@ -592,38 +608,37 @@
           <a:p>
             <a:pPr lvl="0"/>
             <a:r>
-              <a:rPr lang="en-US" smtClean="0"/>
+              <a:rPr lang="en-US"/>
               <a:t>Click to edit Master text styles</a:t>
             </a:r>
           </a:p>
           <a:p>
             <a:pPr lvl="1"/>
             <a:r>
-              <a:rPr lang="en-US" smtClean="0"/>
+              <a:rPr lang="en-US"/>
               <a:t>Second level</a:t>
             </a:r>
           </a:p>
           <a:p>
             <a:pPr lvl="2"/>
             <a:r>
-              <a:rPr lang="en-US" smtClean="0"/>
+              <a:rPr lang="en-US"/>
               <a:t>Third level</a:t>
             </a:r>
           </a:p>
           <a:p>
             <a:pPr lvl="3"/>
             <a:r>
-              <a:rPr lang="en-US" smtClean="0"/>
+              <a:rPr lang="en-US"/>
               <a:t>Fourth level</a:t>
             </a:r>
           </a:p>
           <a:p>
             <a:pPr lvl="4"/>
             <a:r>
-              <a:rPr lang="en-US" smtClean="0"/>
+              <a:rPr lang="en-US"/>
               <a:t>Fifth level</a:t>
             </a:r>
-            <a:endParaRPr lang="en-US"/>
           </a:p>
         </p:txBody>
       </p:sp>
@@ -644,7 +659,7 @@
           <a:p>
             <a:fld id="{5BCAD085-E8A6-8845-BD4E-CB4CCA059FC4}" type="datetimeFigureOut">
               <a:rPr lang="en-US" smtClean="0"/>
-              <a:t>1/27/13</a:t>
+              <a:t>9/18/2026</a:t>
             </a:fld>
             <a:endParaRPr lang="en-US"/>
           </a:p>
@@ -686,7 +701,7 @@
           <a:p>
             <a:fld id="{C1FF6DA9-008F-8B48-92A6-B652298478BF}" type="slidenum">
               <a:rPr lang="en-US" smtClean="0"/>
-              <a:t>‹#›</a:t>
+              <a:t>‹nº›</a:t>
             </a:fld>
             <a:endParaRPr lang="en-US"/>
           </a:p>
@@ -738,10 +753,9 @@
           <a:lstStyle/>
           <a:p>
             <a:r>
-              <a:rPr lang="en-US" smtClean="0"/>
+              <a:rPr lang="en-US"/>
               <a:t>Click to edit Master title style</a:t>
             </a:r>
-            <a:endParaRPr lang="en-US"/>
           </a:p>
         </p:txBody>
       </p:sp>
@@ -762,38 +776,37 @@
           <a:p>
             <a:pPr lvl="0"/>
             <a:r>
-              <a:rPr lang="en-US" smtClean="0"/>
+              <a:rPr lang="en-US"/>
               <a:t>Click to edit Master text styles</a:t>
             </a:r>
           </a:p>
           <a:p>
             <a:pPr lvl="1"/>
             <a:r>
-              <a:rPr lang="en-US" smtClean="0"/>
+              <a:rPr lang="en-US"/>
               <a:t>Second level</a:t>
             </a:r>
           </a:p>
           <a:p>
             <a:pPr lvl="2"/>
             <a:r>
-              <a:rPr lang="en-US" smtClean="0"/>
+              <a:rPr lang="en-US"/>
               <a:t>Third level</a:t>
             </a:r>
           </a:p>
           <a:p>
             <a:pPr lvl="3"/>
             <a:r>
-              <a:rPr lang="en-US" smtClean="0"/>
+              <a:rPr lang="en-US"/>
               <a:t>Fourth level</a:t>
             </a:r>
           </a:p>
           <a:p>
             <a:pPr lvl="4"/>
             <a:r>
-              <a:rPr lang="en-US" smtClean="0"/>
+              <a:rPr lang="en-US"/>
               <a:t>Fifth level</a:t>
             </a:r>
-            <a:endParaRPr lang="en-US"/>
           </a:p>
         </p:txBody>
       </p:sp>
@@ -814,7 +827,7 @@
           <a:p>
             <a:fld id="{5BCAD085-E8A6-8845-BD4E-CB4CCA059FC4}" type="datetimeFigureOut">
               <a:rPr lang="en-US" smtClean="0"/>
-              <a:t>1/27/13</a:t>
+              <a:t>9/18/2026</a:t>
             </a:fld>
             <a:endParaRPr lang="en-US"/>
           </a:p>
@@ -856,7 +869,7 @@
           <a:p>
             <a:fld id="{C1FF6DA9-008F-8B48-92A6-B652298478BF}" type="slidenum">
               <a:rPr lang="en-US" smtClean="0"/>
-              <a:t>‹#›</a:t>
+              <a:t>‹nº›</a:t>
             </a:fld>
             <a:endParaRPr lang="en-US"/>
           </a:p>
@@ -917,10 +930,9 @@
           </a:lstStyle>
           <a:p>
             <a:r>
-              <a:rPr lang="en-US" smtClean="0"/>
+              <a:rPr lang="en-US"/>
               <a:t>Click to edit Master title style</a:t>
             </a:r>
-            <a:endParaRPr lang="en-US"/>
           </a:p>
         </p:txBody>
       </p:sp>
@@ -1037,7 +1049,7 @@
           <a:p>
             <a:pPr lvl="0"/>
             <a:r>
-              <a:rPr lang="en-US" smtClean="0"/>
+              <a:rPr lang="en-US"/>
               <a:t>Click to edit Master text styles</a:t>
             </a:r>
           </a:p>
@@ -1060,7 +1072,7 @@
           <a:p>
             <a:fld id="{5BCAD085-E8A6-8845-BD4E-CB4CCA059FC4}" type="datetimeFigureOut">
               <a:rPr lang="en-US" smtClean="0"/>
-              <a:t>1/27/13</a:t>
+              <a:t>9/18/2026</a:t>
             </a:fld>
             <a:endParaRPr lang="en-US"/>
           </a:p>
@@ -1102,7 +1114,7 @@
           <a:p>
             <a:fld id="{C1FF6DA9-008F-8B48-92A6-B652298478BF}" type="slidenum">
               <a:rPr lang="en-US" smtClean="0"/>
-              <a:t>‹#›</a:t>
+              <a:t>‹nº›</a:t>
             </a:fld>
             <a:endParaRPr lang="en-US"/>
           </a:p>
@@ -1154,10 +1166,9 @@
           <a:lstStyle/>
           <a:p>
             <a:r>
-              <a:rPr lang="en-US" smtClean="0"/>
+              <a:rPr lang="en-US"/>
               <a:t>Click to edit Master title style</a:t>
             </a:r>
-            <a:endParaRPr lang="en-US"/>
           </a:p>
         </p:txBody>
       </p:sp>
@@ -1211,38 +1222,37 @@
           <a:p>
             <a:pPr lvl="0"/>
             <a:r>
-              <a:rPr lang="en-US" smtClean="0"/>
+              <a:rPr lang="en-US"/>
               <a:t>Click to edit Master text styles</a:t>
             </a:r>
           </a:p>
           <a:p>
             <a:pPr lvl="1"/>
             <a:r>
-              <a:rPr lang="en-US" smtClean="0"/>
+              <a:rPr lang="en-US"/>
               <a:t>Second level</a:t>
             </a:r>
           </a:p>
           <a:p>
             <a:pPr lvl="2"/>
             <a:r>
-              <a:rPr lang="en-US" smtClean="0"/>
+              <a:rPr lang="en-US"/>
               <a:t>Third level</a:t>
             </a:r>
           </a:p>
           <a:p>
             <a:pPr lvl="3"/>
             <a:r>
-              <a:rPr lang="en-US" smtClean="0"/>
+              <a:rPr lang="en-US"/>
               <a:t>Fourth level</a:t>
             </a:r>
           </a:p>
           <a:p>
             <a:pPr lvl="4"/>
             <a:r>
-              <a:rPr lang="en-US" smtClean="0"/>
+              <a:rPr lang="en-US"/>
               <a:t>Fifth level</a:t>
             </a:r>
-            <a:endParaRPr lang="en-US"/>
           </a:p>
         </p:txBody>
       </p:sp>
@@ -1296,38 +1306,37 @@
           <a:p>
             <a:pPr lvl="0"/>
             <a:r>
-              <a:rPr lang="en-US" smtClean="0"/>
+              <a:rPr lang="en-US"/>
               <a:t>Click to edit Master text styles</a:t>
             </a:r>
           </a:p>
           <a:p>
             <a:pPr lvl="1"/>
             <a:r>
-              <a:rPr lang="en-US" smtClean="0"/>
+              <a:rPr lang="en-US"/>
               <a:t>Second level</a:t>
             </a:r>
           </a:p>
           <a:p>
             <a:pPr lvl="2"/>
             <a:r>
-              <a:rPr lang="en-US" smtClean="0"/>
+              <a:rPr lang="en-US"/>
               <a:t>Third level</a:t>
             </a:r>
           </a:p>
           <a:p>
             <a:pPr lvl="3"/>
             <a:r>
-              <a:rPr lang="en-US" smtClean="0"/>
+              <a:rPr lang="en-US"/>
               <a:t>Fourth level</a:t>
             </a:r>
           </a:p>
           <a:p>
             <a:pPr lvl="4"/>
             <a:r>
-              <a:rPr lang="en-US" smtClean="0"/>
+              <a:rPr lang="en-US"/>
               <a:t>Fifth level</a:t>
             </a:r>
-            <a:endParaRPr lang="en-US"/>
           </a:p>
         </p:txBody>
       </p:sp>
@@ -1348,7 +1357,7 @@
           <a:p>
             <a:fld id="{5BCAD085-E8A6-8845-BD4E-CB4CCA059FC4}" type="datetimeFigureOut">
               <a:rPr lang="en-US" smtClean="0"/>
-              <a:t>1/27/13</a:t>
+              <a:t>9/18/2026</a:t>
             </a:fld>
             <a:endParaRPr lang="en-US"/>
           </a:p>
@@ -1390,7 +1399,7 @@
           <a:p>
             <a:fld id="{C1FF6DA9-008F-8B48-92A6-B652298478BF}" type="slidenum">
               <a:rPr lang="en-US" smtClean="0"/>
-              <a:t>‹#›</a:t>
+              <a:t>‹nº›</a:t>
             </a:fld>
             <a:endParaRPr lang="en-US"/>
           </a:p>
@@ -1446,10 +1455,9 @@
           </a:lstStyle>
           <a:p>
             <a:r>
-              <a:rPr lang="en-US" smtClean="0"/>
+              <a:rPr lang="en-US"/>
               <a:t>Click to edit Master title style</a:t>
             </a:r>
-            <a:endParaRPr lang="en-US"/>
           </a:p>
         </p:txBody>
       </p:sp>
@@ -1512,7 +1520,7 @@
           <a:p>
             <a:pPr lvl="0"/>
             <a:r>
-              <a:rPr lang="en-US" smtClean="0"/>
+              <a:rPr lang="en-US"/>
               <a:t>Click to edit Master text styles</a:t>
             </a:r>
           </a:p>
@@ -1568,38 +1576,37 @@
           <a:p>
             <a:pPr lvl="0"/>
             <a:r>
-              <a:rPr lang="en-US" smtClean="0"/>
+              <a:rPr lang="en-US"/>
               <a:t>Click to edit Master text styles</a:t>
             </a:r>
           </a:p>
           <a:p>
             <a:pPr lvl="1"/>
             <a:r>
-              <a:rPr lang="en-US" smtClean="0"/>
+              <a:rPr lang="en-US"/>
               <a:t>Second level</a:t>
             </a:r>
           </a:p>
           <a:p>
             <a:pPr lvl="2"/>
             <a:r>
-              <a:rPr lang="en-US" smtClean="0"/>
+              <a:rPr lang="en-US"/>
               <a:t>Third level</a:t>
             </a:r>
           </a:p>
           <a:p>
             <a:pPr lvl="3"/>
             <a:r>
-              <a:rPr lang="en-US" smtClean="0"/>
+              <a:rPr lang="en-US"/>
               <a:t>Fourth level</a:t>
             </a:r>
           </a:p>
           <a:p>
             <a:pPr lvl="4"/>
             <a:r>
-              <a:rPr lang="en-US" smtClean="0"/>
+              <a:rPr lang="en-US"/>
               <a:t>Fifth level</a:t>
             </a:r>
-            <a:endParaRPr lang="en-US"/>
           </a:p>
         </p:txBody>
       </p:sp>
@@ -1662,7 +1669,7 @@
           <a:p>
             <a:pPr lvl="0"/>
             <a:r>
-              <a:rPr lang="en-US" smtClean="0"/>
+              <a:rPr lang="en-US"/>
               <a:t>Click to edit Master text styles</a:t>
             </a:r>
           </a:p>
@@ -1718,38 +1725,37 @@
           <a:p>
             <a:pPr lvl="0"/>
             <a:r>
-              <a:rPr lang="en-US" smtClean="0"/>
+              <a:rPr lang="en-US"/>
               <a:t>Click to edit Master text styles</a:t>
             </a:r>
           </a:p>
           <a:p>
             <a:pPr lvl="1"/>
             <a:r>
-              <a:rPr lang="en-US" smtClean="0"/>
+              <a:rPr lang="en-US"/>
               <a:t>Second level</a:t>
             </a:r>
           </a:p>
           <a:p>
             <a:pPr lvl="2"/>
             <a:r>
-              <a:rPr lang="en-US" smtClean="0"/>
+              <a:rPr lang="en-US"/>
               <a:t>Third level</a:t>
             </a:r>
           </a:p>
           <a:p>
             <a:pPr lvl="3"/>
             <a:r>
-              <a:rPr lang="en-US" smtClean="0"/>
+              <a:rPr lang="en-US"/>
               <a:t>Fourth level</a:t>
             </a:r>
           </a:p>
           <a:p>
             <a:pPr lvl="4"/>
             <a:r>
-              <a:rPr lang="en-US" smtClean="0"/>
+              <a:rPr lang="en-US"/>
               <a:t>Fifth level</a:t>
             </a:r>
-            <a:endParaRPr lang="en-US"/>
           </a:p>
         </p:txBody>
       </p:sp>
@@ -1770,7 +1776,7 @@
           <a:p>
             <a:fld id="{5BCAD085-E8A6-8845-BD4E-CB4CCA059FC4}" type="datetimeFigureOut">
               <a:rPr lang="en-US" smtClean="0"/>
-              <a:t>1/27/13</a:t>
+              <a:t>9/18/2026</a:t>
             </a:fld>
             <a:endParaRPr lang="en-US"/>
           </a:p>
@@ -1812,7 +1818,7 @@
           <a:p>
             <a:fld id="{C1FF6DA9-008F-8B48-92A6-B652298478BF}" type="slidenum">
               <a:rPr lang="en-US" smtClean="0"/>
-              <a:t>‹#›</a:t>
+              <a:t>‹nº›</a:t>
             </a:fld>
             <a:endParaRPr lang="en-US"/>
           </a:p>
@@ -1864,10 +1870,9 @@
           <a:lstStyle/>
           <a:p>
             <a:r>
-              <a:rPr lang="en-US" smtClean="0"/>
+              <a:rPr lang="en-US"/>
               <a:t>Click to edit Master title style</a:t>
             </a:r>
-            <a:endParaRPr lang="en-US"/>
           </a:p>
         </p:txBody>
       </p:sp>
@@ -1888,7 +1893,7 @@
           <a:p>
             <a:fld id="{5BCAD085-E8A6-8845-BD4E-CB4CCA059FC4}" type="datetimeFigureOut">
               <a:rPr lang="en-US" smtClean="0"/>
-              <a:t>1/27/13</a:t>
+              <a:t>9/18/2026</a:t>
             </a:fld>
             <a:endParaRPr lang="en-US"/>
           </a:p>
@@ -1930,7 +1935,7 @@
           <a:p>
             <a:fld id="{C1FF6DA9-008F-8B48-92A6-B652298478BF}" type="slidenum">
               <a:rPr lang="en-US" smtClean="0"/>
-              <a:t>‹#›</a:t>
+              <a:t>‹nº›</a:t>
             </a:fld>
             <a:endParaRPr lang="en-US"/>
           </a:p>
@@ -1983,7 +1988,7 @@
           <a:p>
             <a:fld id="{5BCAD085-E8A6-8845-BD4E-CB4CCA059FC4}" type="datetimeFigureOut">
               <a:rPr lang="en-US" smtClean="0"/>
-              <a:t>1/27/13</a:t>
+              <a:t>9/18/2026</a:t>
             </a:fld>
             <a:endParaRPr lang="en-US"/>
           </a:p>
@@ -2025,7 +2030,7 @@
           <a:p>
             <a:fld id="{C1FF6DA9-008F-8B48-92A6-B652298478BF}" type="slidenum">
               <a:rPr lang="en-US" smtClean="0"/>
-              <a:t>‹#›</a:t>
+              <a:t>‹nº›</a:t>
             </a:fld>
             <a:endParaRPr lang="en-US"/>
           </a:p>
@@ -2086,10 +2091,9 @@
           </a:lstStyle>
           <a:p>
             <a:r>
-              <a:rPr lang="en-US" smtClean="0"/>
+              <a:rPr lang="en-US"/>
               <a:t>Click to edit Master title style</a:t>
             </a:r>
-            <a:endParaRPr lang="en-US"/>
           </a:p>
         </p:txBody>
       </p:sp>
@@ -2143,38 +2147,37 @@
           <a:p>
             <a:pPr lvl="0"/>
             <a:r>
-              <a:rPr lang="en-US" smtClean="0"/>
+              <a:rPr lang="en-US"/>
               <a:t>Click to edit Master text styles</a:t>
             </a:r>
           </a:p>
           <a:p>
             <a:pPr lvl="1"/>
             <a:r>
-              <a:rPr lang="en-US" smtClean="0"/>
+              <a:rPr lang="en-US"/>
               <a:t>Second level</a:t>
             </a:r>
           </a:p>
           <a:p>
             <a:pPr lvl="2"/>
             <a:r>
-              <a:rPr lang="en-US" smtClean="0"/>
+              <a:rPr lang="en-US"/>
               <a:t>Third level</a:t>
             </a:r>
           </a:p>
           <a:p>
             <a:pPr lvl="3"/>
             <a:r>
-              <a:rPr lang="en-US" smtClean="0"/>
+              <a:rPr lang="en-US"/>
               <a:t>Fourth level</a:t>
             </a:r>
           </a:p>
           <a:p>
             <a:pPr lvl="4"/>
             <a:r>
-              <a:rPr lang="en-US" smtClean="0"/>
+              <a:rPr lang="en-US"/>
               <a:t>Fifth level</a:t>
             </a:r>
-            <a:endParaRPr lang="en-US"/>
           </a:p>
         </p:txBody>
       </p:sp>
@@ -2237,7 +2240,7 @@
           <a:p>
             <a:pPr lvl="0"/>
             <a:r>
-              <a:rPr lang="en-US" smtClean="0"/>
+              <a:rPr lang="en-US"/>
               <a:t>Click to edit Master text styles</a:t>
             </a:r>
           </a:p>
@@ -2260,7 +2263,7 @@
           <a:p>
             <a:fld id="{5BCAD085-E8A6-8845-BD4E-CB4CCA059FC4}" type="datetimeFigureOut">
               <a:rPr lang="en-US" smtClean="0"/>
-              <a:t>1/27/13</a:t>
+              <a:t>9/18/2026</a:t>
             </a:fld>
             <a:endParaRPr lang="en-US"/>
           </a:p>
@@ -2302,7 +2305,7 @@
           <a:p>
             <a:fld id="{C1FF6DA9-008F-8B48-92A6-B652298478BF}" type="slidenum">
               <a:rPr lang="en-US" smtClean="0"/>
-              <a:t>‹#›</a:t>
+              <a:t>‹nº›</a:t>
             </a:fld>
             <a:endParaRPr lang="en-US"/>
           </a:p>
@@ -2363,10 +2366,9 @@
           </a:lstStyle>
           <a:p>
             <a:r>
-              <a:rPr lang="en-US" smtClean="0"/>
+              <a:rPr lang="en-US"/>
               <a:t>Click to edit Master title style</a:t>
             </a:r>
-            <a:endParaRPr lang="en-US"/>
           </a:p>
         </p:txBody>
       </p:sp>
@@ -2490,7 +2492,7 @@
           <a:p>
             <a:pPr lvl="0"/>
             <a:r>
-              <a:rPr lang="en-US" smtClean="0"/>
+              <a:rPr lang="en-US"/>
               <a:t>Click to edit Master text styles</a:t>
             </a:r>
           </a:p>
@@ -2513,7 +2515,7 @@
           <a:p>
             <a:fld id="{5BCAD085-E8A6-8845-BD4E-CB4CCA059FC4}" type="datetimeFigureOut">
               <a:rPr lang="en-US" smtClean="0"/>
-              <a:t>1/27/13</a:t>
+              <a:t>9/18/2026</a:t>
             </a:fld>
             <a:endParaRPr lang="en-US"/>
           </a:p>
@@ -2555,7 +2557,7 @@
           <a:p>
             <a:fld id="{C1FF6DA9-008F-8B48-92A6-B652298478BF}" type="slidenum">
               <a:rPr lang="en-US" smtClean="0"/>
-              <a:t>‹#›</a:t>
+              <a:t>‹nº›</a:t>
             </a:fld>
             <a:endParaRPr lang="en-US"/>
           </a:p>
@@ -2578,9 +2580,12 @@
 <p:sldMaster xmlns:a="http://schemas.openxmlformats.org/drawingml/2006/main" xmlns:r="http://schemas.openxmlformats.org/officeDocument/2006/relationships" xmlns:p="http://schemas.openxmlformats.org/presentationml/2006/main">
   <p:cSld>
     <p:bg>
-      <p:bgRef idx="1001">
-        <a:schemeClr val="bg1"/>
-      </p:bgRef>
+      <p:bgPr>
+        <a:solidFill>
+          <a:srgbClr val="1E1E1E"/>
+        </a:solidFill>
+        <a:effectLst/>
+      </p:bgPr>
     </p:bg>
     <p:spTree>
       <p:nvGrpSpPr>
@@ -2622,10 +2627,9 @@
           <a:lstStyle/>
           <a:p>
             <a:r>
-              <a:rPr lang="en-US" smtClean="0"/>
+              <a:rPr lang="en-US"/>
               <a:t>Click to edit Master title style</a:t>
             </a:r>
-            <a:endParaRPr lang="en-US"/>
           </a:p>
         </p:txBody>
       </p:sp>
@@ -2656,38 +2660,37 @@
           <a:p>
             <a:pPr lvl="0"/>
             <a:r>
-              <a:rPr lang="en-US" smtClean="0"/>
+              <a:rPr lang="en-US"/>
               <a:t>Click to edit Master text styles</a:t>
             </a:r>
           </a:p>
           <a:p>
             <a:pPr lvl="1"/>
             <a:r>
-              <a:rPr lang="en-US" smtClean="0"/>
+              <a:rPr lang="en-US"/>
               <a:t>Second level</a:t>
             </a:r>
           </a:p>
           <a:p>
             <a:pPr lvl="2"/>
             <a:r>
-              <a:rPr lang="en-US" smtClean="0"/>
+              <a:rPr lang="en-US"/>
               <a:t>Third level</a:t>
             </a:r>
           </a:p>
           <a:p>
             <a:pPr lvl="3"/>
             <a:r>
-              <a:rPr lang="en-US" smtClean="0"/>
+              <a:rPr lang="en-US"/>
               <a:t>Fourth level</a:t>
             </a:r>
           </a:p>
           <a:p>
             <a:pPr lvl="4"/>
             <a:r>
-              <a:rPr lang="en-US" smtClean="0"/>
+              <a:rPr lang="en-US"/>
               <a:t>Fifth level</a:t>
             </a:r>
-            <a:endParaRPr lang="en-US"/>
           </a:p>
         </p:txBody>
       </p:sp>
@@ -2726,7 +2729,7 @@
           <a:p>
             <a:fld id="{5BCAD085-E8A6-8845-BD4E-CB4CCA059FC4}" type="datetimeFigureOut">
               <a:rPr lang="en-US" smtClean="0"/>
-              <a:t>1/27/13</a:t>
+              <a:t>9/18/2026</a:t>
             </a:fld>
             <a:endParaRPr lang="en-US"/>
           </a:p>
@@ -2804,7 +2807,7 @@
           <a:p>
             <a:fld id="{C1FF6DA9-008F-8B48-92A6-B652298478BF}" type="slidenum">
               <a:rPr lang="en-US" smtClean="0"/>
-              <a:t>‹#›</a:t>
+              <a:t>‹nº›</a:t>
             </a:fld>
             <a:endParaRPr lang="en-US"/>
           </a:p>
@@ -3085,23 +3088,22 @@
 </file>
 
 <file path=ppt/slides/slide1.xml><?xml version="1.0" encoding="utf-8"?>
-<p:sld xmlns:a="http://schemas.openxmlformats.org/drawingml/2006/main" xmlns:p="http://schemas.openxmlformats.org/presentationml/2006/main" xmlns:r="http://schemas.openxmlformats.org/officeDocument/2006/relationships">
+<p:sld xmlns:a="http://schemas.openxmlformats.org/drawingml/2006/main" xmlns:r="http://schemas.openxmlformats.org/officeDocument/2006/relationships" xmlns:p="http://schemas.openxmlformats.org/presentationml/2006/main">
   <p:cSld>
-    <p:bg>
-      <p:bgPr>
-        <a:solidFill>
-          <a:srgbClr val="1E1E1E"/>
-        </a:solidFill>
-        <a:effectLst/>
-      </p:bgPr>
-    </p:bg>
     <p:spTree>
       <p:nvGrpSpPr>
         <p:cNvPr id="1" name=""/>
         <p:cNvGrpSpPr/>
         <p:nvPr/>
       </p:nvGrpSpPr>
-      <p:grpSpPr/>
+      <p:grpSpPr>
+        <a:xfrm>
+          <a:off x="0" y="0"/>
+          <a:ext cx="0" cy="0"/>
+          <a:chOff x="0" y="0"/>
+          <a:chExt cx="0" cy="0"/>
+        </a:xfrm>
+      </p:grpSpPr>
       <p:sp>
         <p:nvSpPr>
           <p:cNvPr id="2" name="TextBox 1"/>
@@ -3111,7 +3113,7 @@
         <p:spPr>
           <a:xfrm>
             <a:off x="914400" y="2286000"/>
-            <a:ext cx="10362895" cy="2743200"/>
+            <a:ext cx="8597546" cy="1631216"/>
           </a:xfrm>
           <a:prstGeom prst="rect">
             <a:avLst/>
@@ -3133,8 +3135,14 @@
               </a:defRPr>
             </a:pPr>
             <a:r>
+              <a:rPr dirty="0"/>
               <a:t>JavaScript + HTML</a:t>
             </a:r>
+            <a:r>
+              <a:rPr lang="pt-BR" dirty="0"/>
+              <a:t> + CSS</a:t>
+            </a:r>
+            <a:endParaRPr dirty="0"/>
           </a:p>
           <a:p>
             <a:pPr>
@@ -3146,7 +3154,24 @@
               </a:defRPr>
             </a:pPr>
             <a:r>
-              <a:t>A Ponte de Interação (Manipulação do DOM)</a:t>
+              <a:rPr dirty="0"/>
+              <a:t>A Ponte de </a:t>
+            </a:r>
+            <a:r>
+              <a:rPr dirty="0" err="1"/>
+              <a:t>Interação</a:t>
+            </a:r>
+            <a:r>
+              <a:rPr dirty="0"/>
+              <a:t> (</a:t>
+            </a:r>
+            <a:r>
+              <a:rPr dirty="0" err="1"/>
+              <a:t>Manipulação</a:t>
+            </a:r>
+            <a:r>
+              <a:rPr dirty="0"/>
+              <a:t> do DOM)</a:t>
             </a:r>
           </a:p>
           <a:p>
@@ -3159,7 +3184,1006 @@
               </a:defRPr>
             </a:pPr>
             <a:r>
-              <a:t>Guia Completo de Aula Prática</a:t>
+              <a:rPr dirty="0" err="1"/>
+              <a:t>Guia</a:t>
+            </a:r>
+            <a:r>
+              <a:rPr dirty="0"/>
+              <a:t> de Aula </a:t>
+            </a:r>
+            <a:r>
+              <a:rPr dirty="0" err="1"/>
+              <a:t>Prática</a:t>
+            </a:r>
+            <a:endParaRPr dirty="0"/>
+          </a:p>
+        </p:txBody>
+      </p:sp>
+    </p:spTree>
+  </p:cSld>
+  <p:clrMapOvr>
+    <a:masterClrMapping/>
+  </p:clrMapOvr>
+</p:sld>
+</file>
+
+<file path=ppt/slides/slide10.xml><?xml version="1.0" encoding="utf-8"?>
+<p:sld xmlns:a="http://schemas.openxmlformats.org/drawingml/2006/main" xmlns:r="http://schemas.openxmlformats.org/officeDocument/2006/relationships" xmlns:p="http://schemas.openxmlformats.org/presentationml/2006/main">
+  <p:cSld>
+    <p:spTree>
+      <p:nvGrpSpPr>
+        <p:cNvPr id="1" name=""/>
+        <p:cNvGrpSpPr/>
+        <p:nvPr/>
+      </p:nvGrpSpPr>
+      <p:grpSpPr>
+        <a:xfrm>
+          <a:off x="0" y="0"/>
+          <a:ext cx="0" cy="0"/>
+          <a:chOff x="0" y="0"/>
+          <a:chExt cx="0" cy="0"/>
+        </a:xfrm>
+      </p:grpSpPr>
+      <p:sp>
+        <p:nvSpPr>
+          <p:cNvPr id="2" name="TextBox 1"/>
+          <p:cNvSpPr txBox="1"/>
+          <p:nvPr/>
+        </p:nvSpPr>
+        <p:spPr>
+          <a:xfrm>
+            <a:off x="548640" y="365760"/>
+            <a:ext cx="11094415" cy="1097280"/>
+          </a:xfrm>
+          <a:prstGeom prst="rect">
+            <a:avLst/>
+          </a:prstGeom>
+          <a:noFill/>
+        </p:spPr>
+        <p:txBody>
+          <a:bodyPr wrap="square" lIns="0" tIns="0" rIns="0" bIns="0">
+            <a:spAutoFit/>
+          </a:bodyPr>
+          <a:lstStyle/>
+          <a:p>
+            <a:pPr>
+              <a:spcAft>
+                <a:spcPts val="400"/>
+              </a:spcAft>
+              <a:defRPr sz="3200" b="1">
+                <a:solidFill>
+                  <a:srgbClr val="F9FAFB"/>
+                </a:solidFill>
+                <a:latin typeface="Arial"/>
+              </a:defRPr>
+            </a:pPr>
+            <a:r>
+              <a:t>2. Estilos Inline vs Alternância de Classes</a:t>
+            </a:r>
+          </a:p>
+          <a:p>
+            <a:pPr>
+              <a:defRPr sz="1400">
+                <a:solidFill>
+                  <a:srgbClr val="9CA3AF"/>
+                </a:solidFill>
+                <a:latin typeface="Arial"/>
+              </a:defRPr>
+            </a:pPr>
+            <a:r>
+              <a:t>A sutil diferença entre controlar design ou comportamento no JavaScript</a:t>
+            </a:r>
+          </a:p>
+        </p:txBody>
+      </p:sp>
+      <p:sp>
+        <p:nvSpPr>
+          <p:cNvPr id="3" name="TextBox 2"/>
+          <p:cNvSpPr txBox="1"/>
+          <p:nvPr/>
+        </p:nvSpPr>
+        <p:spPr>
+          <a:xfrm>
+            <a:off x="548640" y="1828800"/>
+            <a:ext cx="5303520" cy="1969770"/>
+          </a:xfrm>
+          <a:prstGeom prst="rect">
+            <a:avLst/>
+          </a:prstGeom>
+          <a:noFill/>
+        </p:spPr>
+        <p:txBody>
+          <a:bodyPr wrap="square">
+            <a:spAutoFit/>
+          </a:bodyPr>
+          <a:lstStyle/>
+          <a:p>
+            <a:pPr>
+              <a:spcAft>
+                <a:spcPts val="1000"/>
+              </a:spcAft>
+              <a:defRPr sz="1800" b="1">
+                <a:solidFill>
+                  <a:srgbClr val="F9FAFB"/>
+                </a:solidFill>
+                <a:latin typeface="Arial"/>
+              </a:defRPr>
+            </a:pPr>
+            <a:r>
+              <a:rPr dirty="0" err="1"/>
+              <a:t>Modificação</a:t>
+            </a:r>
+            <a:r>
+              <a:rPr dirty="0"/>
+              <a:t> </a:t>
+            </a:r>
+            <a:r>
+              <a:rPr dirty="0" err="1"/>
+              <a:t>Direta</a:t>
+            </a:r>
+            <a:r>
+              <a:rPr dirty="0"/>
+              <a:t> (.style)</a:t>
+            </a:r>
+          </a:p>
+          <a:p>
+            <a:pPr>
+              <a:spcAft>
+                <a:spcPts val="1400"/>
+              </a:spcAft>
+              <a:defRPr sz="1400">
+                <a:solidFill>
+                  <a:srgbClr val="9CA3AF"/>
+                </a:solidFill>
+                <a:latin typeface="Consolas"/>
+              </a:defRPr>
+            </a:pPr>
+            <a:r>
+              <a:rPr dirty="0" err="1"/>
+              <a:t>el.style.backgroundColor</a:t>
+            </a:r>
+            <a:r>
+              <a:rPr dirty="0"/>
+              <a:t> = 'red';</a:t>
+            </a:r>
+            <a:br>
+              <a:rPr dirty="0"/>
+            </a:br>
+            <a:r>
+              <a:rPr dirty="0" err="1"/>
+              <a:t>el.style.fontSize</a:t>
+            </a:r>
+            <a:r>
+              <a:rPr dirty="0"/>
+              <a:t> = '20px';</a:t>
+            </a:r>
+          </a:p>
+          <a:p>
+            <a:pPr>
+              <a:defRPr sz="1400">
+                <a:solidFill>
+                  <a:srgbClr val="9CA3AF"/>
+                </a:solidFill>
+                <a:latin typeface="Arial"/>
+              </a:defRPr>
+            </a:pPr>
+            <a:r>
+              <a:rPr dirty="0"/>
+              <a:t>• </a:t>
+            </a:r>
+            <a:r>
+              <a:rPr dirty="0" err="1"/>
+              <a:t>Injeta</a:t>
+            </a:r>
+            <a:r>
+              <a:rPr dirty="0"/>
+              <a:t> CSS </a:t>
+            </a:r>
+            <a:r>
+              <a:rPr dirty="0" err="1"/>
+              <a:t>direto</a:t>
+            </a:r>
+            <a:r>
+              <a:rPr dirty="0"/>
+              <a:t> </a:t>
+            </a:r>
+            <a:r>
+              <a:rPr dirty="0" err="1"/>
+              <a:t>na</a:t>
+            </a:r>
+            <a:r>
+              <a:rPr dirty="0"/>
+              <a:t> tag (inline).</a:t>
+            </a:r>
+            <a:br>
+              <a:rPr dirty="0"/>
+            </a:br>
+            <a:r>
+              <a:rPr dirty="0">
+                <a:solidFill>
+                  <a:srgbClr val="1E1E1E"/>
+                </a:solidFill>
+              </a:rPr>
+              <a:t>• </a:t>
+            </a:r>
+            <a:r>
+              <a:rPr dirty="0" err="1">
+                <a:solidFill>
+                  <a:srgbClr val="1E1E1E"/>
+                </a:solidFill>
+              </a:rPr>
+              <a:t>Transforma</a:t>
+            </a:r>
+            <a:r>
+              <a:rPr dirty="0">
+                <a:solidFill>
+                  <a:srgbClr val="1E1E1E"/>
+                </a:solidFill>
+              </a:rPr>
+              <a:t> </a:t>
+            </a:r>
+            <a:r>
+              <a:rPr dirty="0" err="1">
+                <a:solidFill>
+                  <a:srgbClr val="1E1E1E"/>
+                </a:solidFill>
+              </a:rPr>
+              <a:t>propriedades</a:t>
+            </a:r>
+            <a:r>
+              <a:rPr dirty="0">
+                <a:solidFill>
+                  <a:srgbClr val="1E1E1E"/>
+                </a:solidFill>
+              </a:rPr>
+              <a:t> com </a:t>
+            </a:r>
+            <a:r>
+              <a:rPr dirty="0" err="1">
+                <a:solidFill>
+                  <a:srgbClr val="1E1E1E"/>
+                </a:solidFill>
+              </a:rPr>
+              <a:t>hífen</a:t>
+            </a:r>
+            <a:r>
+              <a:rPr dirty="0">
+                <a:solidFill>
+                  <a:srgbClr val="1E1E1E"/>
+                </a:solidFill>
+              </a:rPr>
+              <a:t> </a:t>
+            </a:r>
+            <a:r>
+              <a:rPr dirty="0" err="1">
+                <a:solidFill>
+                  <a:srgbClr val="1E1E1E"/>
+                </a:solidFill>
+              </a:rPr>
+              <a:t>em</a:t>
+            </a:r>
+            <a:r>
+              <a:rPr dirty="0">
+                <a:solidFill>
+                  <a:srgbClr val="1E1E1E"/>
+                </a:solidFill>
+              </a:rPr>
+              <a:t> camelCase.</a:t>
+            </a:r>
+            <a:br>
+              <a:rPr dirty="0">
+                <a:solidFill>
+                  <a:srgbClr val="1E1E1E"/>
+                </a:solidFill>
+              </a:rPr>
+            </a:br>
+            <a:r>
+              <a:rPr dirty="0"/>
+              <a:t>• Ideal para </a:t>
+            </a:r>
+            <a:r>
+              <a:rPr dirty="0" err="1"/>
+              <a:t>valores</a:t>
+            </a:r>
+            <a:r>
+              <a:rPr dirty="0"/>
+              <a:t> </a:t>
+            </a:r>
+            <a:r>
+              <a:rPr dirty="0" err="1"/>
+              <a:t>dinâmicos</a:t>
+            </a:r>
+            <a:r>
+              <a:rPr dirty="0"/>
+              <a:t> </a:t>
+            </a:r>
+            <a:r>
+              <a:rPr dirty="0" err="1"/>
+              <a:t>calculados</a:t>
+            </a:r>
+            <a:r>
+              <a:rPr dirty="0"/>
+              <a:t> </a:t>
+            </a:r>
+            <a:r>
+              <a:rPr dirty="0" err="1"/>
+              <a:t>na</a:t>
+            </a:r>
+            <a:r>
+              <a:rPr dirty="0"/>
+              <a:t> hora (ex: </a:t>
+            </a:r>
+            <a:r>
+              <a:rPr dirty="0" err="1"/>
+              <a:t>posição</a:t>
+            </a:r>
+            <a:r>
+              <a:rPr dirty="0"/>
+              <a:t> do mouse).</a:t>
+            </a:r>
+          </a:p>
+        </p:txBody>
+      </p:sp>
+      <p:sp>
+        <p:nvSpPr>
+          <p:cNvPr id="4" name="TextBox 3"/>
+          <p:cNvSpPr txBox="1"/>
+          <p:nvPr/>
+        </p:nvSpPr>
+        <p:spPr>
+          <a:xfrm>
+            <a:off x="6309360" y="1828800"/>
+            <a:ext cx="5303520" cy="4389120"/>
+          </a:xfrm>
+          <a:prstGeom prst="rect">
+            <a:avLst/>
+          </a:prstGeom>
+          <a:noFill/>
+        </p:spPr>
+        <p:txBody>
+          <a:bodyPr wrap="square">
+            <a:spAutoFit/>
+          </a:bodyPr>
+          <a:lstStyle/>
+          <a:p>
+            <a:pPr>
+              <a:spcAft>
+                <a:spcPts val="1000"/>
+              </a:spcAft>
+              <a:defRPr sz="1800" b="1">
+                <a:solidFill>
+                  <a:srgbClr val="10B981"/>
+                </a:solidFill>
+                <a:latin typeface="Arial"/>
+              </a:defRPr>
+            </a:pPr>
+            <a:r>
+              <a:rPr dirty="0" err="1"/>
+              <a:t>Melhor</a:t>
+            </a:r>
+            <a:r>
+              <a:rPr dirty="0"/>
+              <a:t> </a:t>
+            </a:r>
+            <a:r>
+              <a:rPr dirty="0" err="1"/>
+              <a:t>Prática</a:t>
+            </a:r>
+            <a:r>
+              <a:rPr dirty="0"/>
+              <a:t> (.</a:t>
+            </a:r>
+            <a:r>
+              <a:rPr dirty="0" err="1"/>
+              <a:t>classList</a:t>
+            </a:r>
+            <a:r>
+              <a:rPr dirty="0"/>
+              <a:t>)</a:t>
+            </a:r>
+          </a:p>
+          <a:p>
+            <a:pPr>
+              <a:spcAft>
+                <a:spcPts val="1400"/>
+              </a:spcAft>
+              <a:defRPr sz="1400">
+                <a:solidFill>
+                  <a:srgbClr val="10B981"/>
+                </a:solidFill>
+                <a:latin typeface="Consolas"/>
+              </a:defRPr>
+            </a:pPr>
+            <a:r>
+              <a:rPr dirty="0" err="1"/>
+              <a:t>el.classList.add</a:t>
+            </a:r>
+            <a:r>
+              <a:rPr dirty="0"/>
+              <a:t>('modo-</a:t>
+            </a:r>
+            <a:r>
+              <a:rPr dirty="0" err="1"/>
+              <a:t>escuro</a:t>
+            </a:r>
+            <a:r>
+              <a:rPr dirty="0"/>
+              <a:t>');</a:t>
+            </a:r>
+            <a:br>
+              <a:rPr dirty="0"/>
+            </a:br>
+            <a:r>
+              <a:rPr dirty="0" err="1"/>
+              <a:t>el.classList.toggle</a:t>
+            </a:r>
+            <a:r>
+              <a:rPr dirty="0"/>
+              <a:t>('</a:t>
+            </a:r>
+            <a:r>
+              <a:rPr dirty="0" err="1"/>
+              <a:t>ativo</a:t>
+            </a:r>
+            <a:r>
+              <a:rPr dirty="0"/>
+              <a:t>');</a:t>
+            </a:r>
+          </a:p>
+          <a:p>
+            <a:pPr>
+              <a:defRPr sz="1400">
+                <a:solidFill>
+                  <a:srgbClr val="F9FAFB"/>
+                </a:solidFill>
+                <a:latin typeface="Arial"/>
+              </a:defRPr>
+            </a:pPr>
+            <a:r>
+              <a:rPr dirty="0"/>
+              <a:t>• Liga e </a:t>
+            </a:r>
+            <a:r>
+              <a:rPr dirty="0" err="1"/>
+              <a:t>desliga</a:t>
+            </a:r>
+            <a:r>
+              <a:rPr dirty="0"/>
+              <a:t> classes </a:t>
+            </a:r>
+            <a:r>
+              <a:rPr dirty="0" err="1"/>
+              <a:t>declaradas</a:t>
+            </a:r>
+            <a:r>
+              <a:rPr dirty="0"/>
+              <a:t> no CSS.</a:t>
+            </a:r>
+            <a:br>
+              <a:rPr dirty="0"/>
+            </a:br>
+            <a:r>
+              <a:rPr dirty="0"/>
+              <a:t>• </a:t>
+            </a:r>
+            <a:r>
+              <a:rPr dirty="0" err="1"/>
+              <a:t>Mantém</a:t>
+            </a:r>
+            <a:r>
+              <a:rPr dirty="0"/>
+              <a:t> a </a:t>
+            </a:r>
+            <a:r>
+              <a:rPr dirty="0" err="1"/>
+              <a:t>separação</a:t>
+            </a:r>
+            <a:r>
+              <a:rPr dirty="0"/>
+              <a:t>: JS </a:t>
+            </a:r>
+            <a:r>
+              <a:rPr dirty="0" err="1"/>
+              <a:t>cuida</a:t>
+            </a:r>
+            <a:r>
+              <a:rPr dirty="0"/>
+              <a:t> da </a:t>
+            </a:r>
+            <a:r>
+              <a:rPr dirty="0" err="1"/>
+              <a:t>lógica</a:t>
+            </a:r>
+            <a:r>
+              <a:rPr dirty="0"/>
+              <a:t>, CSS do visual.</a:t>
+            </a:r>
+            <a:br>
+              <a:rPr dirty="0"/>
+            </a:br>
+            <a:r>
+              <a:rPr dirty="0"/>
+              <a:t>• </a:t>
+            </a:r>
+            <a:r>
+              <a:rPr dirty="0" err="1"/>
+              <a:t>Muito</a:t>
+            </a:r>
+            <a:r>
+              <a:rPr dirty="0"/>
+              <a:t> </a:t>
+            </a:r>
+            <a:r>
+              <a:rPr dirty="0" err="1"/>
+              <a:t>mais</a:t>
+            </a:r>
+            <a:r>
+              <a:rPr dirty="0"/>
+              <a:t> </a:t>
+            </a:r>
+            <a:r>
+              <a:rPr dirty="0" err="1"/>
+              <a:t>limpo</a:t>
+            </a:r>
+            <a:r>
+              <a:rPr dirty="0"/>
+              <a:t>, </a:t>
+            </a:r>
+            <a:r>
+              <a:rPr dirty="0" err="1"/>
+              <a:t>performático</a:t>
+            </a:r>
+            <a:r>
+              <a:rPr dirty="0"/>
+              <a:t> e </a:t>
+            </a:r>
+            <a:r>
+              <a:rPr dirty="0" err="1"/>
+              <a:t>fácil</a:t>
+            </a:r>
+            <a:r>
+              <a:rPr dirty="0"/>
+              <a:t> de </a:t>
+            </a:r>
+            <a:r>
+              <a:rPr dirty="0" err="1"/>
+              <a:t>manter</a:t>
+            </a:r>
+            <a:r>
+              <a:rPr dirty="0"/>
+              <a:t>.</a:t>
+            </a:r>
+          </a:p>
+        </p:txBody>
+      </p:sp>
+    </p:spTree>
+  </p:cSld>
+  <p:clrMapOvr>
+    <a:masterClrMapping/>
+  </p:clrMapOvr>
+</p:sld>
+</file>
+
+<file path=ppt/slides/slide11.xml><?xml version="1.0" encoding="utf-8"?>
+<p:sld xmlns:a="http://schemas.openxmlformats.org/drawingml/2006/main" xmlns:r="http://schemas.openxmlformats.org/officeDocument/2006/relationships" xmlns:p="http://schemas.openxmlformats.org/presentationml/2006/main">
+  <p:cSld>
+    <p:spTree>
+      <p:nvGrpSpPr>
+        <p:cNvPr id="1" name=""/>
+        <p:cNvGrpSpPr/>
+        <p:nvPr/>
+      </p:nvGrpSpPr>
+      <p:grpSpPr>
+        <a:xfrm>
+          <a:off x="0" y="0"/>
+          <a:ext cx="0" cy="0"/>
+          <a:chOff x="0" y="0"/>
+          <a:chExt cx="0" cy="0"/>
+        </a:xfrm>
+      </p:grpSpPr>
+      <p:sp>
+        <p:nvSpPr>
+          <p:cNvPr id="2" name="TextBox 1"/>
+          <p:cNvSpPr txBox="1"/>
+          <p:nvPr/>
+        </p:nvSpPr>
+        <p:spPr>
+          <a:xfrm>
+            <a:off x="548640" y="365760"/>
+            <a:ext cx="11094415" cy="1097280"/>
+          </a:xfrm>
+          <a:prstGeom prst="rect">
+            <a:avLst/>
+          </a:prstGeom>
+          <a:noFill/>
+        </p:spPr>
+        <p:txBody>
+          <a:bodyPr wrap="square" lIns="0" tIns="0" rIns="0" bIns="0">
+            <a:spAutoFit/>
+          </a:bodyPr>
+          <a:lstStyle/>
+          <a:p>
+            <a:pPr>
+              <a:spcAft>
+                <a:spcPts val="400"/>
+              </a:spcAft>
+              <a:defRPr sz="3200" b="1">
+                <a:solidFill>
+                  <a:srgbClr val="F9FAFB"/>
+                </a:solidFill>
+                <a:latin typeface="Arial"/>
+              </a:defRPr>
+            </a:pPr>
+            <a:r>
+              <a:t>3. Criação Dinâmica de Elementos</a:t>
+            </a:r>
+          </a:p>
+          <a:p>
+            <a:pPr>
+              <a:defRPr sz="1400">
+                <a:solidFill>
+                  <a:srgbClr val="9CA3AF"/>
+                </a:solidFill>
+                <a:latin typeface="Arial"/>
+              </a:defRPr>
+            </a:pPr>
+            <a:r>
+              <a:t>Como construir novos nós na árvore do DOM do absoluto zero</a:t>
+            </a:r>
+          </a:p>
+        </p:txBody>
+      </p:sp>
+      <p:sp>
+        <p:nvSpPr>
+          <p:cNvPr id="3" name="TextBox 2"/>
+          <p:cNvSpPr txBox="1"/>
+          <p:nvPr/>
+        </p:nvSpPr>
+        <p:spPr>
+          <a:xfrm>
+            <a:off x="548640" y="1828800"/>
+            <a:ext cx="11094415" cy="4389120"/>
+          </a:xfrm>
+          <a:prstGeom prst="rect">
+            <a:avLst/>
+          </a:prstGeom>
+          <a:noFill/>
+        </p:spPr>
+        <p:txBody>
+          <a:bodyPr wrap="square">
+            <a:spAutoFit/>
+          </a:bodyPr>
+          <a:lstStyle/>
+          <a:p>
+            <a:pPr>
+              <a:spcAft>
+                <a:spcPts val="200"/>
+              </a:spcAft>
+              <a:defRPr sz="1500" b="1">
+                <a:solidFill>
+                  <a:srgbClr val="9CA3AF"/>
+                </a:solidFill>
+                <a:latin typeface="Arial"/>
+              </a:defRPr>
+            </a:pPr>
+            <a:r>
+              <a:t>Passo 1: Criar o elemento na memória</a:t>
+            </a:r>
+          </a:p>
+          <a:p>
+            <a:pPr>
+              <a:spcAft>
+                <a:spcPts val="1400"/>
+              </a:spcAft>
+              <a:defRPr sz="1300">
+                <a:solidFill>
+                  <a:srgbClr val="F9FAFB"/>
+                </a:solidFill>
+                <a:latin typeface="Consolas"/>
+              </a:defRPr>
+            </a:pPr>
+            <a:r>
+              <a:t>const novoCard = document.createElement('div');</a:t>
+            </a:r>
+          </a:p>
+          <a:p>
+            <a:pPr>
+              <a:spcAft>
+                <a:spcPts val="200"/>
+              </a:spcAft>
+              <a:defRPr sz="1500" b="1">
+                <a:solidFill>
+                  <a:srgbClr val="9CA3AF"/>
+                </a:solidFill>
+                <a:latin typeface="Arial"/>
+              </a:defRPr>
+            </a:pPr>
+            <a:r>
+              <a:t>Passo 2: Alimentar o elemento (Texto, classes, etc)</a:t>
+            </a:r>
+          </a:p>
+          <a:p>
+            <a:pPr>
+              <a:spcAft>
+                <a:spcPts val="1400"/>
+              </a:spcAft>
+              <a:defRPr sz="1300">
+                <a:solidFill>
+                  <a:srgbClr val="F9FAFB"/>
+                </a:solidFill>
+                <a:latin typeface="Consolas"/>
+              </a:defRPr>
+            </a:pPr>
+            <a:r>
+              <a:t>novoCard.textContent = 'Conteúdo do Card';</a:t>
+            </a:r>
+            <a:br/>
+            <a:r>
+              <a:t>novoCard.classList.add('card-estilizado');</a:t>
+            </a:r>
+          </a:p>
+          <a:p>
+            <a:pPr>
+              <a:spcAft>
+                <a:spcPts val="200"/>
+              </a:spcAft>
+              <a:defRPr sz="1500" b="1">
+                <a:solidFill>
+                  <a:srgbClr val="9CA3AF"/>
+                </a:solidFill>
+                <a:latin typeface="Arial"/>
+              </a:defRPr>
+            </a:pPr>
+            <a:r>
+              <a:t>Passo 3: Inserir no HTML real (Anexar ao pai)</a:t>
+            </a:r>
+          </a:p>
+          <a:p>
+            <a:pPr>
+              <a:spcAft>
+                <a:spcPts val="1400"/>
+              </a:spcAft>
+              <a:defRPr sz="1300">
+                <a:solidFill>
+                  <a:srgbClr val="FBBF24"/>
+                </a:solidFill>
+                <a:latin typeface="Consolas"/>
+              </a:defRPr>
+            </a:pPr>
+            <a:r>
+              <a:t>const container = document.querySelector('#painel');</a:t>
+            </a:r>
+            <a:br/>
+            <a:r>
+              <a:t>container.appendChild(novoCard);</a:t>
+            </a:r>
+          </a:p>
+        </p:txBody>
+      </p:sp>
+    </p:spTree>
+  </p:cSld>
+  <p:clrMapOvr>
+    <a:masterClrMapping/>
+  </p:clrMapOvr>
+</p:sld>
+</file>
+
+<file path=ppt/slides/slide12.xml><?xml version="1.0" encoding="utf-8"?>
+<p:sld xmlns:a="http://schemas.openxmlformats.org/drawingml/2006/main" xmlns:r="http://schemas.openxmlformats.org/officeDocument/2006/relationships" xmlns:p="http://schemas.openxmlformats.org/presentationml/2006/main">
+  <p:cSld>
+    <p:spTree>
+      <p:nvGrpSpPr>
+        <p:cNvPr id="1" name=""/>
+        <p:cNvGrpSpPr/>
+        <p:nvPr/>
+      </p:nvGrpSpPr>
+      <p:grpSpPr>
+        <a:xfrm>
+          <a:off x="0" y="0"/>
+          <a:ext cx="0" cy="0"/>
+          <a:chOff x="0" y="0"/>
+          <a:chExt cx="0" cy="0"/>
+        </a:xfrm>
+      </p:grpSpPr>
+      <p:sp>
+        <p:nvSpPr>
+          <p:cNvPr id="2" name="TextBox 1"/>
+          <p:cNvSpPr txBox="1"/>
+          <p:nvPr/>
+        </p:nvSpPr>
+        <p:spPr>
+          <a:xfrm>
+            <a:off x="548640" y="365760"/>
+            <a:ext cx="11094415" cy="1097280"/>
+          </a:xfrm>
+          <a:prstGeom prst="rect">
+            <a:avLst/>
+          </a:prstGeom>
+          <a:noFill/>
+        </p:spPr>
+        <p:txBody>
+          <a:bodyPr wrap="square" lIns="0" tIns="0" rIns="0" bIns="0">
+            <a:spAutoFit/>
+          </a:bodyPr>
+          <a:lstStyle/>
+          <a:p>
+            <a:pPr>
+              <a:spcAft>
+                <a:spcPts val="400"/>
+              </a:spcAft>
+              <a:defRPr sz="3200" b="1">
+                <a:solidFill>
+                  <a:srgbClr val="F9FAFB"/>
+                </a:solidFill>
+                <a:latin typeface="Arial"/>
+              </a:defRPr>
+            </a:pPr>
+            <a:r>
+              <a:t>Resumo Didático: Qual Escolher?</a:t>
+            </a:r>
+          </a:p>
+          <a:p>
+            <a:pPr>
+              <a:defRPr sz="1400">
+                <a:solidFill>
+                  <a:srgbClr val="9CA3AF"/>
+                </a:solidFill>
+                <a:latin typeface="Arial"/>
+              </a:defRPr>
+            </a:pPr>
+            <a:r>
+              <a:t>Guia rápido para tomada de decisão no dia a dia</a:t>
+            </a:r>
+          </a:p>
+        </p:txBody>
+      </p:sp>
+      <p:sp>
+        <p:nvSpPr>
+          <p:cNvPr id="3" name="TextBox 2"/>
+          <p:cNvSpPr txBox="1"/>
+          <p:nvPr/>
+        </p:nvSpPr>
+        <p:spPr>
+          <a:xfrm>
+            <a:off x="548640" y="2011680"/>
+            <a:ext cx="11094415" cy="4114800"/>
+          </a:xfrm>
+          <a:prstGeom prst="rect">
+            <a:avLst/>
+          </a:prstGeom>
+          <a:noFill/>
+        </p:spPr>
+        <p:txBody>
+          <a:bodyPr wrap="square">
+            <a:spAutoFit/>
+          </a:bodyPr>
+          <a:lstStyle/>
+          <a:p>
+            <a:pPr>
+              <a:spcAft>
+                <a:spcPts val="200"/>
+              </a:spcAft>
+              <a:defRPr sz="1600" b="1">
+                <a:solidFill>
+                  <a:srgbClr val="FBBF24"/>
+                </a:solidFill>
+                <a:latin typeface="Arial"/>
+              </a:defRPr>
+            </a:pPr>
+            <a:r>
+              <a:t>❓ Alterar apenas texto simples?</a:t>
+            </a:r>
+          </a:p>
+          <a:p>
+            <a:pPr>
+              <a:spcAft>
+                <a:spcPts val="1200"/>
+              </a:spcAft>
+              <a:defRPr sz="1500">
+                <a:solidFill>
+                  <a:srgbClr val="F9FAFB"/>
+                </a:solidFill>
+                <a:latin typeface="Arial"/>
+              </a:defRPr>
+            </a:pPr>
+            <a:r>
+              <a:t>👉 Use .textContent (Rápido e 100% seguro)</a:t>
+            </a:r>
+          </a:p>
+          <a:p>
+            <a:pPr>
+              <a:spcAft>
+                <a:spcPts val="200"/>
+              </a:spcAft>
+              <a:defRPr sz="1600" b="1">
+                <a:solidFill>
+                  <a:srgbClr val="FBBF24"/>
+                </a:solidFill>
+                <a:latin typeface="Arial"/>
+              </a:defRPr>
+            </a:pPr>
+            <a:r>
+              <a:t>❓ Inserir formatação ou tags HTML vindas do seu próprio código?</a:t>
+            </a:r>
+          </a:p>
+          <a:p>
+            <a:pPr>
+              <a:spcAft>
+                <a:spcPts val="1200"/>
+              </a:spcAft>
+              <a:defRPr sz="1500">
+                <a:solidFill>
+                  <a:srgbClr val="F9FAFB"/>
+                </a:solidFill>
+                <a:latin typeface="Arial"/>
+              </a:defRPr>
+            </a:pPr>
+            <a:r>
+              <a:t>👉 Use .innerHTML (Cuidado com dados de terceiros)</a:t>
+            </a:r>
+          </a:p>
+          <a:p>
+            <a:pPr>
+              <a:spcAft>
+                <a:spcPts val="200"/>
+              </a:spcAft>
+              <a:defRPr sz="1600" b="1">
+                <a:solidFill>
+                  <a:srgbClr val="FBBF24"/>
+                </a:solidFill>
+                <a:latin typeface="Arial"/>
+              </a:defRPr>
+            </a:pPr>
+            <a:r>
+              <a:t>❓ Alterar o visual com base em estados (ex: Ativo/Inativo, Dia/Noite)?</a:t>
+            </a:r>
+          </a:p>
+          <a:p>
+            <a:pPr>
+              <a:spcAft>
+                <a:spcPts val="1200"/>
+              </a:spcAft>
+              <a:defRPr sz="1500">
+                <a:solidFill>
+                  <a:srgbClr val="F9FAFB"/>
+                </a:solidFill>
+                <a:latin typeface="Arial"/>
+              </a:defRPr>
+            </a:pPr>
+            <a:r>
+              <a:t>👉 Use .classList.toggle() (A melhor prática de arquitetura)</a:t>
+            </a:r>
+          </a:p>
+          <a:p>
+            <a:pPr>
+              <a:spcAft>
+                <a:spcPts val="200"/>
+              </a:spcAft>
+              <a:defRPr sz="1600" b="1">
+                <a:solidFill>
+                  <a:srgbClr val="FBBF24"/>
+                </a:solidFill>
+                <a:latin typeface="Arial"/>
+              </a:defRPr>
+            </a:pPr>
+            <a:r>
+              <a:t>❓ Criar novos blocos, comentários ou itens de lista dinamicamente?</a:t>
+            </a:r>
+          </a:p>
+          <a:p>
+            <a:pPr>
+              <a:spcAft>
+                <a:spcPts val="1200"/>
+              </a:spcAft>
+              <a:defRPr sz="1500">
+                <a:solidFill>
+                  <a:srgbClr val="F9FAFB"/>
+                </a:solidFill>
+                <a:latin typeface="Arial"/>
+              </a:defRPr>
+            </a:pPr>
+            <a:r>
+              <a:t>👉 Use .createElement() + .appendChild()</a:t>
             </a:r>
           </a:p>
         </p:txBody>
@@ -3173,23 +4197,22 @@
 </file>
 
 <file path=ppt/slides/slide2.xml><?xml version="1.0" encoding="utf-8"?>
-<p:sld xmlns:a="http://schemas.openxmlformats.org/drawingml/2006/main" xmlns:p="http://schemas.openxmlformats.org/presentationml/2006/main" xmlns:r="http://schemas.openxmlformats.org/officeDocument/2006/relationships">
+<p:sld xmlns:a="http://schemas.openxmlformats.org/drawingml/2006/main" xmlns:r="http://schemas.openxmlformats.org/officeDocument/2006/relationships" xmlns:p="http://schemas.openxmlformats.org/presentationml/2006/main">
   <p:cSld>
-    <p:bg>
-      <p:bgPr>
-        <a:solidFill>
-          <a:srgbClr val="1E1E1E"/>
-        </a:solidFill>
-        <a:effectLst/>
-      </p:bgPr>
-    </p:bg>
     <p:spTree>
       <p:nvGrpSpPr>
         <p:cNvPr id="1" name=""/>
         <p:cNvGrpSpPr/>
         <p:nvPr/>
       </p:nvGrpSpPr>
-      <p:grpSpPr/>
+      <p:grpSpPr>
+        <a:xfrm>
+          <a:off x="0" y="0"/>
+          <a:ext cx="0" cy="0"/>
+          <a:chOff x="0" y="0"/>
+          <a:chExt cx="0" cy="0"/>
+        </a:xfrm>
+      </p:grpSpPr>
       <p:sp>
         <p:nvSpPr>
           <p:cNvPr id="2" name="TextBox 1"/>
@@ -3286,6 +4309,7 @@
               <a:t>O JS localiza a tag no HTML que queremos monitorar ou alterar usando o ID.</a:t>
             </a:r>
             <a:br/>
+            <a:endParaRPr/>
           </a:p>
           <a:p>
             <a:pPr>
@@ -3313,6 +4337,7 @@
               <a:t>O JS fica de guarda vigiando as ações do usuário (eventos como o 'click').</a:t>
             </a:r>
             <a:br/>
+            <a:endParaRPr/>
           </a:p>
           <a:p>
             <a:pPr>
@@ -3340,6 +4365,7 @@
               <a:t>O JS executa a lógica e altera o conteúdo da tela em tempo real.</a:t>
             </a:r>
             <a:br/>
+            <a:endParaRPr/>
           </a:p>
         </p:txBody>
       </p:sp>
@@ -3352,23 +4378,22 @@
 </file>
 
 <file path=ppt/slides/slide3.xml><?xml version="1.0" encoding="utf-8"?>
-<p:sld xmlns:a="http://schemas.openxmlformats.org/drawingml/2006/main" xmlns:p="http://schemas.openxmlformats.org/presentationml/2006/main" xmlns:r="http://schemas.openxmlformats.org/officeDocument/2006/relationships">
+<p:sld xmlns:a="http://schemas.openxmlformats.org/drawingml/2006/main" xmlns:r="http://schemas.openxmlformats.org/officeDocument/2006/relationships" xmlns:p="http://schemas.openxmlformats.org/presentationml/2006/main">
   <p:cSld>
-    <p:bg>
-      <p:bgPr>
-        <a:solidFill>
-          <a:srgbClr val="1E1E1E"/>
-        </a:solidFill>
-        <a:effectLst/>
-      </p:bgPr>
-    </p:bg>
     <p:spTree>
       <p:nvGrpSpPr>
         <p:cNvPr id="1" name=""/>
         <p:cNvGrpSpPr/>
         <p:nvPr/>
       </p:nvGrpSpPr>
-      <p:grpSpPr/>
+      <p:grpSpPr>
+        <a:xfrm>
+          <a:off x="0" y="0"/>
+          <a:ext cx="0" cy="0"/>
+          <a:chOff x="0" y="0"/>
+          <a:chExt cx="0" cy="0"/>
+        </a:xfrm>
+      </p:grpSpPr>
       <p:sp>
         <p:nvSpPr>
           <p:cNvPr id="2" name="TextBox 1"/>
@@ -3426,7 +4451,7 @@
         </p:nvSpPr>
         <p:spPr>
           <a:xfrm>
-            <a:off x="914400" y="2011680"/>
+            <a:off x="914399" y="2110292"/>
             <a:ext cx="10362895" cy="4114800"/>
           </a:xfrm>
           <a:prstGeom prst="rect">
@@ -3449,51 +4474,247 @@
               </a:defRPr>
             </a:pPr>
             <a:r>
+              <a:rPr dirty="0"/>
               <a:t>&lt;!DOCTYPE html&gt;</a:t>
             </a:r>
-            <a:br/>
-            <a:r>
-              <a:t>&lt;html lang="pt-BR"&gt;</a:t>
-            </a:r>
-            <a:br/>
-            <a:r>
+            <a:br>
+              <a:rPr dirty="0"/>
+            </a:br>
+            <a:r>
+              <a:rPr dirty="0"/>
+              <a:t>&lt;html </a:t>
+            </a:r>
+            <a:r>
+              <a:rPr dirty="0" err="1"/>
+              <a:t>lang</a:t>
+            </a:r>
+            <a:r>
+              <a:rPr dirty="0"/>
+              <a:t>="</a:t>
+            </a:r>
+            <a:r>
+              <a:rPr dirty="0" err="1"/>
+              <a:t>pt</a:t>
+            </a:r>
+            <a:r>
+              <a:rPr dirty="0"/>
+              <a:t>-BR"&gt;</a:t>
+            </a:r>
+            <a:br>
+              <a:rPr dirty="0"/>
+            </a:br>
+            <a:r>
+              <a:rPr dirty="0"/>
               <a:t>&lt;body&gt;</a:t>
             </a:r>
-            <a:br/>
-            <a:r>
-              <a:t>    &lt;h1&gt;Painel de Boas-Vindas&lt;/h1&gt;</a:t>
-            </a:r>
-            <a:br/>
-            <a:r>
-              <a:t>    &lt;input type="text" id="campoNome" placeholder="Digite seu nome"&gt;</a:t>
-            </a:r>
-            <a:br/>
-            <a:r>
-              <a:t>    &lt;button id="btnDia"&gt;Desejar Bom Dia&lt;/button&gt;</a:t>
-            </a:r>
-            <a:br/>
-            <a:r>
-              <a:t>    &lt;button id="btnNoite"&gt;Desejar Boa Noite&lt;/button&gt;</a:t>
-            </a:r>
-            <a:br/>
-            <a:r>
-              <a:t>    &lt;div id="painelResultado"&gt;&lt;p&gt;Aguardando...&lt;/p&gt;&lt;/div&gt;</a:t>
-            </a:r>
-            <a:br/>
-            <a:br/>
-            <a:r>
-              <a:t>    &lt;!-- Ligação com o arquivo de lógica externa --&gt;</a:t>
-            </a:r>
-            <a:br/>
-            <a:r>
-              <a:t>    &lt;script src="script.js"&gt;&lt;/script&gt;</a:t>
-            </a:r>
-            <a:br/>
-            <a:r>
+            <a:br>
+              <a:rPr dirty="0"/>
+            </a:br>
+            <a:r>
+              <a:rPr dirty="0"/>
+              <a:t>    &lt;h1&gt;</a:t>
+            </a:r>
+            <a:r>
+              <a:rPr dirty="0" err="1"/>
+              <a:t>Painel</a:t>
+            </a:r>
+            <a:r>
+              <a:rPr dirty="0"/>
+              <a:t> de Boas-</a:t>
+            </a:r>
+            <a:r>
+              <a:rPr dirty="0" err="1"/>
+              <a:t>Vindas</a:t>
+            </a:r>
+            <a:r>
+              <a:rPr dirty="0"/>
+              <a:t>&lt;/h1&gt;</a:t>
+            </a:r>
+            <a:br>
+              <a:rPr dirty="0"/>
+            </a:br>
+            <a:r>
+              <a:rPr dirty="0"/>
+              <a:t>    &lt;input type="text" id="</a:t>
+            </a:r>
+            <a:r>
+              <a:rPr dirty="0" err="1"/>
+              <a:t>campoNome</a:t>
+            </a:r>
+            <a:r>
+              <a:rPr dirty="0"/>
+              <a:t>" placeholder="</a:t>
+            </a:r>
+            <a:r>
+              <a:rPr dirty="0" err="1"/>
+              <a:t>Digite</a:t>
+            </a:r>
+            <a:r>
+              <a:rPr dirty="0"/>
+              <a:t> </a:t>
+            </a:r>
+            <a:r>
+              <a:rPr dirty="0" err="1"/>
+              <a:t>seu</a:t>
+            </a:r>
+            <a:r>
+              <a:rPr dirty="0"/>
+              <a:t> </a:t>
+            </a:r>
+            <a:r>
+              <a:rPr dirty="0" err="1"/>
+              <a:t>nome</a:t>
+            </a:r>
+            <a:r>
+              <a:rPr dirty="0"/>
+              <a:t>"&gt;</a:t>
+            </a:r>
+            <a:br>
+              <a:rPr dirty="0"/>
+            </a:br>
+            <a:r>
+              <a:rPr dirty="0"/>
+              <a:t>    &lt;button id="</a:t>
+            </a:r>
+            <a:r>
+              <a:rPr dirty="0" err="1"/>
+              <a:t>btnDia</a:t>
+            </a:r>
+            <a:r>
+              <a:rPr dirty="0"/>
+              <a:t>"&gt;</a:t>
+            </a:r>
+            <a:r>
+              <a:rPr dirty="0" err="1"/>
+              <a:t>Desejar</a:t>
+            </a:r>
+            <a:r>
+              <a:rPr dirty="0"/>
+              <a:t> Bom </a:t>
+            </a:r>
+            <a:r>
+              <a:rPr dirty="0" err="1"/>
+              <a:t>Dia</a:t>
+            </a:r>
+            <a:r>
+              <a:rPr dirty="0"/>
+              <a:t>&lt;/button&gt;</a:t>
+            </a:r>
+            <a:br>
+              <a:rPr dirty="0"/>
+            </a:br>
+            <a:r>
+              <a:rPr dirty="0"/>
+              <a:t>    &lt;button id="</a:t>
+            </a:r>
+            <a:r>
+              <a:rPr dirty="0" err="1"/>
+              <a:t>btnNoite</a:t>
+            </a:r>
+            <a:r>
+              <a:rPr dirty="0"/>
+              <a:t>"&gt;</a:t>
+            </a:r>
+            <a:r>
+              <a:rPr dirty="0" err="1"/>
+              <a:t>Desejar</a:t>
+            </a:r>
+            <a:r>
+              <a:rPr dirty="0"/>
+              <a:t> Boa </a:t>
+            </a:r>
+            <a:r>
+              <a:rPr dirty="0" err="1"/>
+              <a:t>Noite</a:t>
+            </a:r>
+            <a:r>
+              <a:rPr dirty="0"/>
+              <a:t>&lt;/button&gt;</a:t>
+            </a:r>
+            <a:br>
+              <a:rPr dirty="0"/>
+            </a:br>
+            <a:r>
+              <a:rPr dirty="0"/>
+              <a:t>    &lt;div id="</a:t>
+            </a:r>
+            <a:r>
+              <a:rPr dirty="0" err="1"/>
+              <a:t>painelResultado</a:t>
+            </a:r>
+            <a:r>
+              <a:rPr dirty="0"/>
+              <a:t>"&gt;&lt;p&gt;</a:t>
+            </a:r>
+            <a:r>
+              <a:rPr dirty="0" err="1"/>
+              <a:t>Aguardando</a:t>
+            </a:r>
+            <a:r>
+              <a:rPr dirty="0"/>
+              <a:t>...&lt;/p&gt;&lt;/div&gt;</a:t>
+            </a:r>
+            <a:br>
+              <a:rPr dirty="0"/>
+            </a:br>
+            <a:br>
+              <a:rPr dirty="0"/>
+            </a:br>
+            <a:r>
+              <a:rPr dirty="0"/>
+              <a:t>    &lt;!-- </a:t>
+            </a:r>
+            <a:r>
+              <a:rPr dirty="0" err="1"/>
+              <a:t>Ligação</a:t>
+            </a:r>
+            <a:r>
+              <a:rPr dirty="0"/>
+              <a:t> com o </a:t>
+            </a:r>
+            <a:r>
+              <a:rPr dirty="0" err="1"/>
+              <a:t>arquivo</a:t>
+            </a:r>
+            <a:r>
+              <a:rPr dirty="0"/>
+              <a:t> de </a:t>
+            </a:r>
+            <a:r>
+              <a:rPr dirty="0" err="1"/>
+              <a:t>lógica</a:t>
+            </a:r>
+            <a:r>
+              <a:rPr dirty="0"/>
+              <a:t> externa --&gt;</a:t>
+            </a:r>
+            <a:br>
+              <a:rPr dirty="0"/>
+            </a:br>
+            <a:r>
+              <a:rPr dirty="0"/>
+              <a:t>    &lt;script </a:t>
+            </a:r>
+            <a:r>
+              <a:rPr dirty="0" err="1"/>
+              <a:t>src</a:t>
+            </a:r>
+            <a:r>
+              <a:rPr dirty="0"/>
+              <a:t>="script.js"&gt;&lt;/script&gt;</a:t>
+            </a:r>
+            <a:br>
+              <a:rPr dirty="0"/>
+            </a:br>
+            <a:r>
+              <a:rPr dirty="0"/>
               <a:t>&lt;/body&gt;</a:t>
             </a:r>
-            <a:br/>
-            <a:r>
+            <a:br>
+              <a:rPr dirty="0"/>
+            </a:br>
+            <a:r>
+              <a:rPr dirty="0"/>
               <a:t>&lt;/html&gt;</a:t>
             </a:r>
           </a:p>
@@ -3508,23 +4729,22 @@
 </file>
 
 <file path=ppt/slides/slide4.xml><?xml version="1.0" encoding="utf-8"?>
-<p:sld xmlns:a="http://schemas.openxmlformats.org/drawingml/2006/main" xmlns:p="http://schemas.openxmlformats.org/presentationml/2006/main" xmlns:r="http://schemas.openxmlformats.org/officeDocument/2006/relationships">
+<p:sld xmlns:a="http://schemas.openxmlformats.org/drawingml/2006/main" xmlns:r="http://schemas.openxmlformats.org/officeDocument/2006/relationships" xmlns:p="http://schemas.openxmlformats.org/presentationml/2006/main">
   <p:cSld>
-    <p:bg>
-      <p:bgPr>
-        <a:solidFill>
-          <a:srgbClr val="1E1E1E"/>
-        </a:solidFill>
-        <a:effectLst/>
-      </p:bgPr>
-    </p:bg>
     <p:spTree>
       <p:nvGrpSpPr>
         <p:cNvPr id="1" name=""/>
         <p:cNvGrpSpPr/>
         <p:nvPr/>
       </p:nvGrpSpPr>
-      <p:grpSpPr/>
+      <p:grpSpPr>
+        <a:xfrm>
+          <a:off x="0" y="0"/>
+          <a:ext cx="0" cy="0"/>
+          <a:chOff x="0" y="0"/>
+          <a:chExt cx="0" cy="0"/>
+        </a:xfrm>
+      </p:grpSpPr>
       <p:sp>
         <p:nvSpPr>
           <p:cNvPr id="2" name="TextBox 1"/>
@@ -3605,57 +4825,276 @@
               </a:defRPr>
             </a:pPr>
             <a:r>
+              <a:rPr dirty="0"/>
               <a:t>// PASSO 1: SELECIONAR OS ELEMENTOS</a:t>
             </a:r>
-            <a:br/>
-            <a:r>
-              <a:t>const caixaTexto = document.querySelector('#campoNome');</a:t>
-            </a:r>
-            <a:br/>
-            <a:r>
-              <a:t>const botaoDia = document.querySelector('#btnDia');</a:t>
-            </a:r>
-            <a:br/>
-            <a:r>
-              <a:t>const areaResultado = document.querySelector('#painelResultado');</a:t>
-            </a:r>
-            <a:br/>
-            <a:br/>
-            <a:r>
+            <a:br>
+              <a:rPr dirty="0"/>
+            </a:br>
+            <a:r>
+              <a:rPr dirty="0"/>
+              <a:t>const </a:t>
+            </a:r>
+            <a:r>
+              <a:rPr dirty="0" err="1"/>
+              <a:t>caixaTexto</a:t>
+            </a:r>
+            <a:r>
+              <a:rPr dirty="0"/>
+              <a:t> = </a:t>
+            </a:r>
+            <a:r>
+              <a:rPr dirty="0" err="1"/>
+              <a:t>document.querySelector</a:t>
+            </a:r>
+            <a:r>
+              <a:rPr dirty="0"/>
+              <a:t>('#</a:t>
+            </a:r>
+            <a:r>
+              <a:rPr dirty="0" err="1"/>
+              <a:t>campoNome</a:t>
+            </a:r>
+            <a:r>
+              <a:rPr dirty="0"/>
+              <a:t>');</a:t>
+            </a:r>
+            <a:br>
+              <a:rPr dirty="0"/>
+            </a:br>
+            <a:r>
+              <a:rPr dirty="0"/>
+              <a:t>const </a:t>
+            </a:r>
+            <a:r>
+              <a:rPr dirty="0" err="1"/>
+              <a:t>botaoDia</a:t>
+            </a:r>
+            <a:r>
+              <a:rPr dirty="0"/>
+              <a:t> = </a:t>
+            </a:r>
+            <a:r>
+              <a:rPr dirty="0" err="1"/>
+              <a:t>document.querySelector</a:t>
+            </a:r>
+            <a:r>
+              <a:rPr dirty="0"/>
+              <a:t>('#</a:t>
+            </a:r>
+            <a:r>
+              <a:rPr dirty="0" err="1"/>
+              <a:t>btnDia</a:t>
+            </a:r>
+            <a:r>
+              <a:rPr dirty="0"/>
+              <a:t>');</a:t>
+            </a:r>
+            <a:br>
+              <a:rPr dirty="0"/>
+            </a:br>
+            <a:r>
+              <a:rPr dirty="0"/>
+              <a:t>const </a:t>
+            </a:r>
+            <a:r>
+              <a:rPr dirty="0" err="1"/>
+              <a:t>areaResultado</a:t>
+            </a:r>
+            <a:r>
+              <a:rPr dirty="0"/>
+              <a:t> = </a:t>
+            </a:r>
+            <a:r>
+              <a:rPr dirty="0" err="1"/>
+              <a:t>document.querySelector</a:t>
+            </a:r>
+            <a:r>
+              <a:rPr dirty="0"/>
+              <a:t>('#</a:t>
+            </a:r>
+            <a:r>
+              <a:rPr dirty="0" err="1"/>
+              <a:t>painelResultado</a:t>
+            </a:r>
+            <a:r>
+              <a:rPr dirty="0"/>
+              <a:t>');</a:t>
+            </a:r>
+            <a:br>
+              <a:rPr dirty="0"/>
+            </a:br>
+            <a:br>
+              <a:rPr dirty="0"/>
+            </a:br>
+            <a:r>
+              <a:rPr dirty="0"/>
               <a:t>// PASSO 2 &amp; 3: ESCUTAR E MODIFICAR</a:t>
             </a:r>
-            <a:br/>
-            <a:r>
-              <a:t>botaoDia.addEventListener('click', function() {</a:t>
-            </a:r>
-            <a:br/>
-            <a:r>
-              <a:t>    let nomeUsuario = caixaTexto.value; // Pega o texto do input</a:t>
-            </a:r>
-            <a:br/>
-            <a:br/>
-            <a:r>
-              <a:t>    if (nomeUsuario === "") {</a:t>
-            </a:r>
-            <a:br/>
-            <a:r>
-              <a:t>        nomeUsuario = "Visitante";</a:t>
-            </a:r>
-            <a:br/>
-            <a:r>
+            <a:br>
+              <a:rPr dirty="0"/>
+            </a:br>
+            <a:r>
+              <a:rPr dirty="0" err="1"/>
+              <a:t>botaoDia.addEventListener</a:t>
+            </a:r>
+            <a:r>
+              <a:rPr dirty="0"/>
+              <a:t>('click', function() {</a:t>
+            </a:r>
+            <a:br>
+              <a:rPr dirty="0"/>
+            </a:br>
+            <a:r>
+              <a:rPr dirty="0"/>
+              <a:t>    let </a:t>
+            </a:r>
+            <a:r>
+              <a:rPr dirty="0" err="1"/>
+              <a:t>nomeUsuario</a:t>
+            </a:r>
+            <a:r>
+              <a:rPr dirty="0"/>
+              <a:t> = </a:t>
+            </a:r>
+            <a:r>
+              <a:rPr dirty="0" err="1"/>
+              <a:t>caixaTexto.value</a:t>
+            </a:r>
+            <a:r>
+              <a:rPr dirty="0"/>
+              <a:t>; // </a:t>
+            </a:r>
+            <a:r>
+              <a:rPr dirty="0" err="1"/>
+              <a:t>Pega</a:t>
+            </a:r>
+            <a:r>
+              <a:rPr dirty="0"/>
+              <a:t> o </a:t>
+            </a:r>
+            <a:r>
+              <a:rPr dirty="0" err="1"/>
+              <a:t>texto</a:t>
+            </a:r>
+            <a:r>
+              <a:rPr dirty="0"/>
+              <a:t> do input</a:t>
+            </a:r>
+            <a:br>
+              <a:rPr dirty="0"/>
+            </a:br>
+            <a:br>
+              <a:rPr dirty="0"/>
+            </a:br>
+            <a:r>
+              <a:rPr dirty="0"/>
+              <a:t>    if (</a:t>
+            </a:r>
+            <a:r>
+              <a:rPr dirty="0" err="1"/>
+              <a:t>nomeUsuario</a:t>
+            </a:r>
+            <a:r>
+              <a:rPr dirty="0"/>
+              <a:t> === "") {</a:t>
+            </a:r>
+            <a:br>
+              <a:rPr dirty="0"/>
+            </a:br>
+            <a:r>
+              <a:rPr dirty="0"/>
+              <a:t>        </a:t>
+            </a:r>
+            <a:r>
+              <a:rPr dirty="0" err="1"/>
+              <a:t>nomeUsuario</a:t>
+            </a:r>
+            <a:r>
+              <a:rPr dirty="0"/>
+              <a:t> = "</a:t>
+            </a:r>
+            <a:r>
+              <a:rPr dirty="0" err="1"/>
+              <a:t>Visitante</a:t>
+            </a:r>
+            <a:r>
+              <a:rPr dirty="0"/>
+              <a:t>";</a:t>
+            </a:r>
+            <a:br>
+              <a:rPr dirty="0"/>
+            </a:br>
+            <a:r>
+              <a:rPr dirty="0"/>
               <a:t>    }</a:t>
             </a:r>
-            <a:br/>
-            <a:br/>
-            <a:r>
-              <a:t>    // Injeta texto puro com total segurança</a:t>
-            </a:r>
-            <a:br/>
-            <a:r>
-              <a:t>    areaResultado.textContent = `☀️ Bom dia, ${nomeUsuario}!`;</a:t>
-            </a:r>
-            <a:br/>
-            <a:r>
+            <a:br>
+              <a:rPr dirty="0"/>
+            </a:br>
+            <a:br>
+              <a:rPr dirty="0"/>
+            </a:br>
+            <a:r>
+              <a:rPr dirty="0"/>
+              <a:t>    // </a:t>
+            </a:r>
+            <a:r>
+              <a:rPr dirty="0" err="1"/>
+              <a:t>Injeta</a:t>
+            </a:r>
+            <a:r>
+              <a:rPr dirty="0"/>
+              <a:t> </a:t>
+            </a:r>
+            <a:r>
+              <a:rPr dirty="0" err="1"/>
+              <a:t>texto</a:t>
+            </a:r>
+            <a:r>
+              <a:rPr dirty="0"/>
+              <a:t> puro com total </a:t>
+            </a:r>
+            <a:r>
+              <a:rPr dirty="0" err="1"/>
+              <a:t>segurança</a:t>
+            </a:r>
+            <a:br>
+              <a:rPr dirty="0"/>
+            </a:br>
+            <a:r>
+              <a:rPr dirty="0"/>
+              <a:t>    </a:t>
+            </a:r>
+            <a:r>
+              <a:rPr dirty="0" err="1"/>
+              <a:t>areaResultado.textContent</a:t>
+            </a:r>
+            <a:r>
+              <a:rPr dirty="0"/>
+              <a:t> = `☀️ Bom </a:t>
+            </a:r>
+            <a:r>
+              <a:rPr dirty="0" err="1"/>
+              <a:t>dia</a:t>
+            </a:r>
+            <a:r>
+              <a:rPr dirty="0"/>
+              <a:t>, ${</a:t>
+            </a:r>
+            <a:r>
+              <a:rPr dirty="0" err="1"/>
+              <a:t>nomeUsuario</a:t>
+            </a:r>
+            <a:r>
+              <a:rPr dirty="0"/>
+              <a:t>}!`;</a:t>
+            </a:r>
+            <a:br>
+              <a:rPr dirty="0"/>
+            </a:br>
+            <a:r>
+              <a:rPr dirty="0"/>
               <a:t>});</a:t>
             </a:r>
           </a:p>
@@ -3670,23 +5109,22 @@
 </file>
 
 <file path=ppt/slides/slide5.xml><?xml version="1.0" encoding="utf-8"?>
-<p:sld xmlns:a="http://schemas.openxmlformats.org/drawingml/2006/main" xmlns:p="http://schemas.openxmlformats.org/presentationml/2006/main" xmlns:r="http://schemas.openxmlformats.org/officeDocument/2006/relationships">
+<p:sld xmlns:a="http://schemas.openxmlformats.org/drawingml/2006/main" xmlns:r="http://schemas.openxmlformats.org/officeDocument/2006/relationships" xmlns:p="http://schemas.openxmlformats.org/presentationml/2006/main">
   <p:cSld>
-    <p:bg>
-      <p:bgPr>
-        <a:solidFill>
-          <a:srgbClr val="1E1E1E"/>
-        </a:solidFill>
-        <a:effectLst/>
-      </p:bgPr>
-    </p:bg>
     <p:spTree>
       <p:nvGrpSpPr>
         <p:cNvPr id="1" name=""/>
         <p:cNvGrpSpPr/>
         <p:nvPr/>
       </p:nvGrpSpPr>
-      <p:grpSpPr/>
+      <p:grpSpPr>
+        <a:xfrm>
+          <a:off x="0" y="0"/>
+          <a:ext cx="0" cy="0"/>
+          <a:chOff x="0" y="0"/>
+          <a:chExt cx="0" cy="0"/>
+        </a:xfrm>
+      </p:grpSpPr>
       <p:sp>
         <p:nvSpPr>
           <p:cNvPr id="2" name="TextBox 1"/>
@@ -3783,6 +5221,7 @@
               <a:t>Usa obrigatoriamente a hashtag '#' para indicar que busca um ID do HTML.</a:t>
             </a:r>
             <a:br/>
+            <a:endParaRPr/>
           </a:p>
           <a:p>
             <a:pPr>
@@ -3810,6 +5249,7 @@
               <a:t>Propriedade usada ÚNICA E EXCLUSIVAMENTE para ler ou escrever dados dentro de campos de entrada (&lt;input&gt;).</a:t>
             </a:r>
             <a:br/>
+            <a:endParaRPr/>
           </a:p>
           <a:p>
             <a:pPr>
@@ -3837,6 +5277,7 @@
               <a:t>Propriedade usada para alterar o texto interno visível de tags como &lt;div&gt;, &lt;p&gt;, &lt;span&gt; ou &lt;h1&gt;.</a:t>
             </a:r>
             <a:br/>
+            <a:endParaRPr/>
           </a:p>
         </p:txBody>
       </p:sp>
@@ -3849,23 +5290,22 @@
 </file>
 
 <file path=ppt/slides/slide6.xml><?xml version="1.0" encoding="utf-8"?>
-<p:sld xmlns:a="http://schemas.openxmlformats.org/drawingml/2006/main" xmlns:p="http://schemas.openxmlformats.org/presentationml/2006/main" xmlns:r="http://schemas.openxmlformats.org/officeDocument/2006/relationships">
+<p:sld xmlns:a="http://schemas.openxmlformats.org/drawingml/2006/main" xmlns:r="http://schemas.openxmlformats.org/officeDocument/2006/relationships" xmlns:p="http://schemas.openxmlformats.org/presentationml/2006/main">
   <p:cSld>
-    <p:bg>
-      <p:bgPr>
-        <a:solidFill>
-          <a:srgbClr val="1E1E1E"/>
-        </a:solidFill>
-        <a:effectLst/>
-      </p:bgPr>
-    </p:bg>
     <p:spTree>
       <p:nvGrpSpPr>
         <p:cNvPr id="1" name=""/>
         <p:cNvGrpSpPr/>
         <p:nvPr/>
       </p:nvGrpSpPr>
-      <p:grpSpPr/>
+      <p:grpSpPr>
+        <a:xfrm>
+          <a:off x="0" y="0"/>
+          <a:ext cx="0" cy="0"/>
+          <a:chOff x="0" y="0"/>
+          <a:chExt cx="0" cy="0"/>
+        </a:xfrm>
+      </p:grpSpPr>
       <p:sp>
         <p:nvSpPr>
           <p:cNvPr id="2" name="TextBox 1"/>
@@ -3875,7 +5315,7 @@
         <p:spPr>
           <a:xfrm>
             <a:off x="457200" y="457200"/>
-            <a:ext cx="11277295" cy="1371600"/>
+            <a:ext cx="11277295" cy="923330"/>
           </a:xfrm>
           <a:prstGeom prst="rect">
             <a:avLst/>
@@ -3897,8 +5337,38 @@
               </a:defRPr>
             </a:pPr>
             <a:r>
-              <a:t>🛑 Erros Comuns dos Alunos na Bancada</a:t>
-            </a:r>
+              <a:rPr dirty="0"/>
+              <a:t>🛑 </a:t>
+            </a:r>
+            <a:r>
+              <a:rPr dirty="0" err="1"/>
+              <a:t>Erros</a:t>
+            </a:r>
+            <a:r>
+              <a:rPr dirty="0"/>
+              <a:t> </a:t>
+            </a:r>
+            <a:r>
+              <a:rPr dirty="0" err="1"/>
+              <a:t>Comuns</a:t>
+            </a:r>
+            <a:r>
+              <a:rPr dirty="0"/>
+              <a:t> </a:t>
+            </a:r>
+            <a:r>
+              <a:rPr dirty="0" err="1"/>
+              <a:t>na</a:t>
+            </a:r>
+            <a:r>
+              <a:rPr dirty="0"/>
+              <a:t> </a:t>
+            </a:r>
+            <a:r>
+              <a:rPr dirty="0" err="1"/>
+              <a:t>Bancada</a:t>
+            </a:r>
+            <a:endParaRPr dirty="0"/>
           </a:p>
           <a:p>
             <a:pPr>
@@ -3910,7 +5380,56 @@
               </a:defRPr>
             </a:pPr>
             <a:r>
-              <a:t>Fique de olho nestes 3 deslizes clássicos durante o laboratório:</a:t>
+              <a:rPr dirty="0"/>
+              <a:t>Fique de </a:t>
+            </a:r>
+            <a:r>
+              <a:rPr dirty="0" err="1"/>
+              <a:t>olho</a:t>
+            </a:r>
+            <a:r>
+              <a:rPr dirty="0"/>
+              <a:t> </a:t>
+            </a:r>
+            <a:r>
+              <a:rPr dirty="0" err="1"/>
+              <a:t>nestes</a:t>
+            </a:r>
+            <a:r>
+              <a:rPr dirty="0"/>
+              <a:t> 3 </a:t>
+            </a:r>
+            <a:r>
+              <a:rPr dirty="0" err="1"/>
+              <a:t>deslizes</a:t>
+            </a:r>
+            <a:r>
+              <a:rPr dirty="0"/>
+              <a:t> </a:t>
+            </a:r>
+            <a:r>
+              <a:rPr dirty="0" err="1"/>
+              <a:t>clássicos</a:t>
+            </a:r>
+            <a:r>
+              <a:rPr dirty="0"/>
+              <a:t> </a:t>
+            </a:r>
+            <a:r>
+              <a:rPr dirty="0" err="1"/>
+              <a:t>durante</a:t>
+            </a:r>
+            <a:r>
+              <a:rPr dirty="0"/>
+              <a:t> o </a:t>
+            </a:r>
+            <a:r>
+              <a:rPr dirty="0" err="1"/>
+              <a:t>laboratório</a:t>
+            </a:r>
+            <a:r>
+              <a:rPr dirty="0"/>
+              <a:t>:</a:t>
             </a:r>
           </a:p>
         </p:txBody>
@@ -3962,6 +5481,7 @@
               <a:t>Escrever querySelector('campoNome'). O JS não acha o elemento e retorna 'null'.</a:t>
             </a:r>
             <a:br/>
+            <a:endParaRPr/>
           </a:p>
           <a:p>
             <a:pPr>
@@ -3989,6 +5509,7 @@
               <a:t>Escrever .value(). O correto é apenas .value, pois é um atributo/propriedade, não uma função.</a:t>
             </a:r>
             <a:br/>
+            <a:endParaRPr/>
           </a:p>
           <a:p>
             <a:pPr>
@@ -4016,6 +5537,7 @@
               <a:t>O aluno altera o JS, testa no navegador e nada muda. Verifique se há uma bolinha branca na aba do VS Code.</a:t>
             </a:r>
             <a:br/>
+            <a:endParaRPr/>
           </a:p>
         </p:txBody>
       </p:sp>
@@ -4028,23 +5550,22 @@
 </file>
 
 <file path=ppt/slides/slide7.xml><?xml version="1.0" encoding="utf-8"?>
-<p:sld xmlns:a="http://schemas.openxmlformats.org/drawingml/2006/main" xmlns:p="http://schemas.openxmlformats.org/presentationml/2006/main" xmlns:r="http://schemas.openxmlformats.org/officeDocument/2006/relationships">
+<p:sld xmlns:a="http://schemas.openxmlformats.org/drawingml/2006/main" xmlns:r="http://schemas.openxmlformats.org/officeDocument/2006/relationships" xmlns:p="http://schemas.openxmlformats.org/presentationml/2006/main">
   <p:cSld>
-    <p:bg>
-      <p:bgPr>
-        <a:solidFill>
-          <a:srgbClr val="1E1E1E"/>
-        </a:solidFill>
-        <a:effectLst/>
-      </p:bgPr>
-    </p:bg>
     <p:spTree>
       <p:nvGrpSpPr>
         <p:cNvPr id="1" name=""/>
         <p:cNvGrpSpPr/>
         <p:nvPr/>
       </p:nvGrpSpPr>
-      <p:grpSpPr/>
+      <p:grpSpPr>
+        <a:xfrm>
+          <a:off x="0" y="0"/>
+          <a:ext cx="0" cy="0"/>
+          <a:chOff x="0" y="0"/>
+          <a:chExt cx="0" cy="0"/>
+        </a:xfrm>
+      </p:grpSpPr>
       <p:sp>
         <p:nvSpPr>
           <p:cNvPr id="2" name="TextBox 1"/>
@@ -4054,7 +5575,7 @@
         <p:spPr>
           <a:xfrm>
             <a:off x="457200" y="457200"/>
-            <a:ext cx="11277295" cy="1371600"/>
+            <a:ext cx="11277295" cy="923330"/>
           </a:xfrm>
           <a:prstGeom prst="rect">
             <a:avLst/>
@@ -4076,8 +5597,22 @@
               </a:defRPr>
             </a:pPr>
             <a:r>
-              <a:t>🎯 Desafio Prático Próximos 20 Minutos</a:t>
-            </a:r>
+              <a:rPr dirty="0"/>
+              <a:t>🎯 </a:t>
+            </a:r>
+            <a:r>
+              <a:rPr dirty="0" err="1"/>
+              <a:t>Desafio</a:t>
+            </a:r>
+            <a:r>
+              <a:rPr dirty="0"/>
+              <a:t> </a:t>
+            </a:r>
+            <a:r>
+              <a:rPr dirty="0" err="1"/>
+              <a:t>Prático</a:t>
+            </a:r>
+            <a:endParaRPr dirty="0"/>
           </a:p>
           <a:p>
             <a:pPr>
@@ -4089,7 +5624,40 @@
               </a:defRPr>
             </a:pPr>
             <a:r>
-              <a:t>Hora de colocar a turma para construir de forma independente:</a:t>
+              <a:rPr dirty="0"/>
+              <a:t>Hora de </a:t>
+            </a:r>
+            <a:r>
+              <a:rPr dirty="0" err="1"/>
+              <a:t>colocar</a:t>
+            </a:r>
+            <a:r>
+              <a:rPr dirty="0"/>
+              <a:t> a </a:t>
+            </a:r>
+            <a:r>
+              <a:rPr dirty="0" err="1"/>
+              <a:t>turma</a:t>
+            </a:r>
+            <a:r>
+              <a:rPr dirty="0"/>
+              <a:t> para </a:t>
+            </a:r>
+            <a:r>
+              <a:rPr dirty="0" err="1"/>
+              <a:t>construir</a:t>
+            </a:r>
+            <a:r>
+              <a:rPr dirty="0"/>
+              <a:t> de forma </a:t>
+            </a:r>
+            <a:r>
+              <a:rPr dirty="0" err="1"/>
+              <a:t>independente</a:t>
+            </a:r>
+            <a:r>
+              <a:rPr dirty="0"/>
+              <a:t>:</a:t>
             </a:r>
           </a:p>
         </p:txBody>
@@ -4103,7 +5671,7 @@
         <p:spPr>
           <a:xfrm>
             <a:off x="914400" y="2286000"/>
-            <a:ext cx="10362895" cy="4114800"/>
+            <a:ext cx="10362895" cy="1661993"/>
           </a:xfrm>
           <a:prstGeom prst="rect">
             <a:avLst/>
@@ -4125,7 +5693,16 @@
               </a:defRPr>
             </a:pPr>
             <a:r>
-              <a:t>O Enunciado para os Alunos:</a:t>
+              <a:rPr dirty="0"/>
+              <a:t>O </a:t>
+            </a:r>
+            <a:r>
+              <a:rPr dirty="0" err="1"/>
+              <a:t>Enunciado</a:t>
+            </a:r>
+            <a:r>
+              <a:rPr dirty="0"/>
+              <a:t>:</a:t>
             </a:r>
           </a:p>
           <a:p>
@@ -4138,19 +5715,1195 @@
               </a:defRPr>
             </a:pPr>
             <a:r>
-              <a:t>"Adicionem um terceiro botão no HTML com o id='btnSair'.</a:t>
-            </a:r>
-            <a:br/>
-            <a:r>
-              <a:t>No arquivo JavaScript, criem um escutador para esse botão.</a:t>
-            </a:r>
-            <a:br/>
-            <a:r>
-              <a:t>Quando ele for clicado, ele deve ler o nome do campo e injetar na tela a mensagem:</a:t>
-            </a:r>
-            <a:br/>
-            <a:r>
-              <a:t>👋 Tchau, [Nome]! Até a próxima aula!"</a:t>
+              <a:rPr dirty="0"/>
+              <a:t>"</a:t>
+            </a:r>
+            <a:r>
+              <a:rPr dirty="0" err="1"/>
+              <a:t>Adicionem</a:t>
+            </a:r>
+            <a:r>
+              <a:rPr dirty="0"/>
+              <a:t> um </a:t>
+            </a:r>
+            <a:r>
+              <a:rPr dirty="0" err="1"/>
+              <a:t>terceiro</a:t>
+            </a:r>
+            <a:r>
+              <a:rPr dirty="0"/>
+              <a:t> </a:t>
+            </a:r>
+            <a:r>
+              <a:rPr dirty="0" err="1"/>
+              <a:t>botão</a:t>
+            </a:r>
+            <a:r>
+              <a:rPr dirty="0"/>
+              <a:t> no HTML com o id='</a:t>
+            </a:r>
+            <a:r>
+              <a:rPr dirty="0" err="1"/>
+              <a:t>btnSair</a:t>
+            </a:r>
+            <a:r>
+              <a:rPr dirty="0"/>
+              <a:t>'.</a:t>
+            </a:r>
+            <a:br>
+              <a:rPr dirty="0"/>
+            </a:br>
+            <a:r>
+              <a:rPr dirty="0"/>
+              <a:t>No </a:t>
+            </a:r>
+            <a:r>
+              <a:rPr dirty="0" err="1"/>
+              <a:t>arquivo</a:t>
+            </a:r>
+            <a:r>
+              <a:rPr dirty="0"/>
+              <a:t> JavaScript, </a:t>
+            </a:r>
+            <a:r>
+              <a:rPr dirty="0" err="1"/>
+              <a:t>criem</a:t>
+            </a:r>
+            <a:r>
+              <a:rPr dirty="0"/>
+              <a:t> um </a:t>
+            </a:r>
+            <a:r>
+              <a:rPr dirty="0" err="1"/>
+              <a:t>escutador</a:t>
+            </a:r>
+            <a:r>
+              <a:rPr dirty="0"/>
+              <a:t> para </a:t>
+            </a:r>
+            <a:r>
+              <a:rPr dirty="0" err="1"/>
+              <a:t>esse</a:t>
+            </a:r>
+            <a:r>
+              <a:rPr dirty="0"/>
+              <a:t> </a:t>
+            </a:r>
+            <a:r>
+              <a:rPr dirty="0" err="1"/>
+              <a:t>botão</a:t>
+            </a:r>
+            <a:r>
+              <a:rPr dirty="0"/>
+              <a:t>.</a:t>
+            </a:r>
+            <a:br>
+              <a:rPr dirty="0"/>
+            </a:br>
+            <a:r>
+              <a:rPr dirty="0" err="1"/>
+              <a:t>Quando</a:t>
+            </a:r>
+            <a:r>
+              <a:rPr dirty="0"/>
+              <a:t> </a:t>
+            </a:r>
+            <a:r>
+              <a:rPr dirty="0" err="1"/>
+              <a:t>ele</a:t>
+            </a:r>
+            <a:r>
+              <a:rPr dirty="0"/>
+              <a:t> for </a:t>
+            </a:r>
+            <a:r>
+              <a:rPr dirty="0" err="1"/>
+              <a:t>clicado</a:t>
+            </a:r>
+            <a:r>
+              <a:rPr dirty="0"/>
+              <a:t>, </a:t>
+            </a:r>
+            <a:r>
+              <a:rPr dirty="0" err="1"/>
+              <a:t>ele</a:t>
+            </a:r>
+            <a:r>
+              <a:rPr dirty="0"/>
+              <a:t> </a:t>
+            </a:r>
+            <a:r>
+              <a:rPr dirty="0" err="1"/>
+              <a:t>deve</a:t>
+            </a:r>
+            <a:r>
+              <a:rPr dirty="0"/>
+              <a:t> </a:t>
+            </a:r>
+            <a:r>
+              <a:rPr dirty="0" err="1"/>
+              <a:t>ler</a:t>
+            </a:r>
+            <a:r>
+              <a:rPr dirty="0"/>
+              <a:t> o </a:t>
+            </a:r>
+            <a:r>
+              <a:rPr dirty="0" err="1"/>
+              <a:t>nome</a:t>
+            </a:r>
+            <a:r>
+              <a:rPr dirty="0"/>
+              <a:t> do campo e </a:t>
+            </a:r>
+            <a:r>
+              <a:rPr dirty="0" err="1"/>
+              <a:t>injetar</a:t>
+            </a:r>
+            <a:r>
+              <a:rPr dirty="0"/>
+              <a:t> </a:t>
+            </a:r>
+            <a:r>
+              <a:rPr dirty="0" err="1"/>
+              <a:t>na</a:t>
+            </a:r>
+            <a:r>
+              <a:rPr dirty="0"/>
+              <a:t> </a:t>
+            </a:r>
+            <a:r>
+              <a:rPr dirty="0" err="1"/>
+              <a:t>tela</a:t>
+            </a:r>
+            <a:r>
+              <a:rPr dirty="0"/>
+              <a:t> a </a:t>
+            </a:r>
+            <a:r>
+              <a:rPr dirty="0" err="1"/>
+              <a:t>mensagem</a:t>
+            </a:r>
+            <a:r>
+              <a:rPr dirty="0"/>
+              <a:t>:</a:t>
+            </a:r>
+            <a:br>
+              <a:rPr dirty="0"/>
+            </a:br>
+            <a:r>
+              <a:rPr dirty="0"/>
+              <a:t>👋 </a:t>
+            </a:r>
+            <a:r>
+              <a:rPr dirty="0" err="1"/>
+              <a:t>Tchau</a:t>
+            </a:r>
+            <a:r>
+              <a:rPr dirty="0"/>
+              <a:t>, [Nome]! </a:t>
+            </a:r>
+            <a:r>
+              <a:rPr dirty="0" err="1"/>
+              <a:t>Até</a:t>
+            </a:r>
+            <a:r>
+              <a:rPr dirty="0"/>
+              <a:t> a </a:t>
+            </a:r>
+            <a:r>
+              <a:rPr dirty="0" err="1"/>
+              <a:t>próxima</a:t>
+            </a:r>
+            <a:r>
+              <a:rPr dirty="0"/>
+              <a:t> aula!"</a:t>
+            </a:r>
+          </a:p>
+        </p:txBody>
+      </p:sp>
+    </p:spTree>
+  </p:cSld>
+  <p:clrMapOvr>
+    <a:masterClrMapping/>
+  </p:clrMapOvr>
+</p:sld>
+</file>
+
+<file path=ppt/slides/slide8.xml><?xml version="1.0" encoding="utf-8"?>
+<p:sld xmlns:a="http://schemas.openxmlformats.org/drawingml/2006/main" xmlns:r="http://schemas.openxmlformats.org/officeDocument/2006/relationships" xmlns:p="http://schemas.openxmlformats.org/presentationml/2006/main">
+  <p:cSld>
+    <p:spTree>
+      <p:nvGrpSpPr>
+        <p:cNvPr id="1" name=""/>
+        <p:cNvGrpSpPr/>
+        <p:nvPr/>
+      </p:nvGrpSpPr>
+      <p:grpSpPr>
+        <a:xfrm>
+          <a:off x="0" y="0"/>
+          <a:ext cx="0" cy="0"/>
+          <a:chOff x="0" y="0"/>
+          <a:chExt cx="0" cy="0"/>
+        </a:xfrm>
+      </p:grpSpPr>
+      <p:sp>
+        <p:nvSpPr>
+          <p:cNvPr id="2" name="TextBox 1"/>
+          <p:cNvSpPr txBox="1"/>
+          <p:nvPr/>
+        </p:nvSpPr>
+        <p:spPr>
+          <a:xfrm>
+            <a:off x="548640" y="365760"/>
+            <a:ext cx="11094415" cy="1097280"/>
+          </a:xfrm>
+          <a:prstGeom prst="rect">
+            <a:avLst/>
+          </a:prstGeom>
+          <a:noFill/>
+        </p:spPr>
+        <p:txBody>
+          <a:bodyPr wrap="square" lIns="0" tIns="0" rIns="0" bIns="0">
+            <a:spAutoFit/>
+          </a:bodyPr>
+          <a:lstStyle/>
+          <a:p>
+            <a:pPr>
+              <a:spcAft>
+                <a:spcPts val="400"/>
+              </a:spcAft>
+              <a:defRPr sz="3200" b="1">
+                <a:solidFill>
+                  <a:srgbClr val="F9FAFB"/>
+                </a:solidFill>
+                <a:latin typeface="Arial"/>
+              </a:defRPr>
+            </a:pPr>
+            <a:r>
+              <a:t>Além do textContent</a:t>
+            </a:r>
+          </a:p>
+          <a:p>
+            <a:pPr>
+              <a:defRPr sz="1400">
+                <a:solidFill>
+                  <a:srgbClr val="9CA3AF"/>
+                </a:solidFill>
+                <a:latin typeface="Arial"/>
+              </a:defRPr>
+            </a:pPr>
+            <a:r>
+              <a:t>A jornada para tornar suas interfaces web dinâmicas e interativas</a:t>
+            </a:r>
+          </a:p>
+        </p:txBody>
+      </p:sp>
+      <p:sp>
+        <p:nvSpPr>
+          <p:cNvPr id="3" name="TextBox 2"/>
+          <p:cNvSpPr txBox="1"/>
+          <p:nvPr/>
+        </p:nvSpPr>
+        <p:spPr>
+          <a:xfrm>
+            <a:off x="548640" y="2011680"/>
+            <a:ext cx="5303520" cy="3631763"/>
+          </a:xfrm>
+          <a:prstGeom prst="rect">
+            <a:avLst/>
+          </a:prstGeom>
+          <a:noFill/>
+        </p:spPr>
+        <p:txBody>
+          <a:bodyPr wrap="square">
+            <a:spAutoFit/>
+          </a:bodyPr>
+          <a:lstStyle/>
+          <a:p>
+            <a:pPr>
+              <a:spcAft>
+                <a:spcPts val="1400"/>
+              </a:spcAft>
+              <a:defRPr sz="2200" b="1">
+                <a:solidFill>
+                  <a:srgbClr val="FBBF24"/>
+                </a:solidFill>
+                <a:latin typeface="Arial"/>
+              </a:defRPr>
+            </a:pPr>
+            <a:r>
+              <a:rPr dirty="0"/>
+              <a:t>O que </a:t>
+            </a:r>
+            <a:r>
+              <a:rPr dirty="0" err="1"/>
+              <a:t>vimos</a:t>
+            </a:r>
+            <a:r>
+              <a:rPr dirty="0"/>
+              <a:t> </a:t>
+            </a:r>
+            <a:r>
+              <a:rPr dirty="0" err="1"/>
+              <a:t>ontem</a:t>
+            </a:r>
+            <a:r>
+              <a:rPr dirty="0"/>
+              <a:t>?</a:t>
+            </a:r>
+          </a:p>
+          <a:p>
+            <a:pPr>
+              <a:spcAft>
+                <a:spcPts val="1000"/>
+              </a:spcAft>
+              <a:defRPr sz="1500">
+                <a:solidFill>
+                  <a:srgbClr val="F9FAFB"/>
+                </a:solidFill>
+                <a:latin typeface="Arial"/>
+              </a:defRPr>
+            </a:pPr>
+            <a:r>
+              <a:rPr dirty="0"/>
+              <a:t>• </a:t>
+            </a:r>
+            <a:r>
+              <a:rPr dirty="0" err="1"/>
+              <a:t>textContent</a:t>
+            </a:r>
+            <a:r>
+              <a:rPr dirty="0"/>
+              <a:t> altera </a:t>
+            </a:r>
+            <a:r>
+              <a:rPr dirty="0" err="1"/>
+              <a:t>apenas</a:t>
+            </a:r>
+            <a:r>
+              <a:rPr dirty="0"/>
+              <a:t> </a:t>
+            </a:r>
+            <a:r>
+              <a:rPr dirty="0" err="1"/>
+              <a:t>texto</a:t>
+            </a:r>
+            <a:r>
+              <a:rPr dirty="0"/>
+              <a:t> puro.</a:t>
+            </a:r>
+          </a:p>
+          <a:p>
+            <a:pPr>
+              <a:spcAft>
+                <a:spcPts val="1000"/>
+              </a:spcAft>
+              <a:defRPr sz="1500">
+                <a:solidFill>
+                  <a:srgbClr val="F9FAFB"/>
+                </a:solidFill>
+                <a:latin typeface="Arial"/>
+              </a:defRPr>
+            </a:pPr>
+            <a:r>
+              <a:rPr dirty="0"/>
+              <a:t>• </a:t>
+            </a:r>
+            <a:r>
+              <a:rPr dirty="0" err="1"/>
+              <a:t>Excelente</a:t>
+            </a:r>
+            <a:r>
+              <a:rPr dirty="0"/>
+              <a:t> para </a:t>
+            </a:r>
+            <a:r>
+              <a:rPr dirty="0" err="1"/>
+              <a:t>segurança</a:t>
+            </a:r>
+            <a:r>
+              <a:rPr dirty="0"/>
+              <a:t> (</a:t>
+            </a:r>
+            <a:r>
+              <a:rPr dirty="0" err="1"/>
+              <a:t>evita</a:t>
+            </a:r>
+            <a:r>
+              <a:rPr dirty="0"/>
+              <a:t> </a:t>
+            </a:r>
+            <a:r>
+              <a:rPr dirty="0" err="1"/>
+              <a:t>injeção</a:t>
+            </a:r>
+            <a:r>
+              <a:rPr dirty="0"/>
+              <a:t> de </a:t>
+            </a:r>
+            <a:r>
+              <a:rPr dirty="0" err="1"/>
+              <a:t>código</a:t>
+            </a:r>
+            <a:r>
+              <a:rPr dirty="0"/>
+              <a:t>).</a:t>
+            </a:r>
+          </a:p>
+          <a:p>
+            <a:pPr>
+              <a:spcAft>
+                <a:spcPts val="1000"/>
+              </a:spcAft>
+              <a:defRPr sz="1500">
+                <a:solidFill>
+                  <a:srgbClr val="F9FAFB"/>
+                </a:solidFill>
+                <a:latin typeface="Arial"/>
+              </a:defRPr>
+            </a:pPr>
+            <a:r>
+              <a:rPr dirty="0"/>
+              <a:t>• </a:t>
+            </a:r>
+            <a:r>
+              <a:rPr dirty="0" err="1"/>
+              <a:t>Limitado</a:t>
+            </a:r>
+            <a:r>
+              <a:rPr dirty="0"/>
+              <a:t>: </a:t>
+            </a:r>
+            <a:r>
+              <a:rPr dirty="0" err="1"/>
+              <a:t>não</a:t>
+            </a:r>
+            <a:r>
+              <a:rPr dirty="0"/>
+              <a:t> </a:t>
+            </a:r>
+            <a:r>
+              <a:rPr dirty="0" err="1"/>
+              <a:t>estiliza</a:t>
+            </a:r>
+            <a:r>
+              <a:rPr dirty="0"/>
+              <a:t> e </a:t>
+            </a:r>
+            <a:r>
+              <a:rPr dirty="0" err="1"/>
+              <a:t>não</a:t>
+            </a:r>
+            <a:r>
+              <a:rPr dirty="0"/>
+              <a:t> </a:t>
+            </a:r>
+            <a:r>
+              <a:rPr dirty="0" err="1"/>
+              <a:t>cria</a:t>
+            </a:r>
+            <a:r>
+              <a:rPr dirty="0"/>
+              <a:t> </a:t>
+            </a:r>
+            <a:r>
+              <a:rPr dirty="0" err="1"/>
+              <a:t>novas</a:t>
+            </a:r>
+            <a:r>
+              <a:rPr dirty="0"/>
+              <a:t> </a:t>
+            </a:r>
+            <a:r>
+              <a:rPr dirty="0" err="1"/>
+              <a:t>estruturas</a:t>
+            </a:r>
+            <a:r>
+              <a:rPr dirty="0"/>
+              <a:t>.</a:t>
+            </a:r>
+            <a:endParaRPr lang="pt-BR" dirty="0"/>
+          </a:p>
+          <a:p>
+            <a:pPr>
+              <a:spcAft>
+                <a:spcPts val="1000"/>
+              </a:spcAft>
+              <a:defRPr sz="1500">
+                <a:solidFill>
+                  <a:srgbClr val="F9FAFB"/>
+                </a:solidFill>
+                <a:latin typeface="Arial"/>
+              </a:defRPr>
+            </a:pPr>
+            <a:endParaRPr lang="pt-BR" dirty="0"/>
+          </a:p>
+          <a:p>
+            <a:r>
+              <a:rPr lang="pt-BR" sz="1400" dirty="0">
+                <a:solidFill>
+                  <a:schemeClr val="bg1"/>
+                </a:solidFill>
+              </a:rPr>
+              <a:t>Vamos </a:t>
+            </a:r>
+            <a:r>
+              <a:rPr lang="pt-BR" sz="1400" dirty="0" err="1">
+                <a:solidFill>
+                  <a:schemeClr val="bg1"/>
+                </a:solidFill>
+              </a:rPr>
+              <a:t>add</a:t>
+            </a:r>
+            <a:r>
+              <a:rPr lang="pt-BR" sz="1400" dirty="0">
+                <a:solidFill>
+                  <a:schemeClr val="bg1"/>
+                </a:solidFill>
+              </a:rPr>
+              <a:t> ao nosso HTML:</a:t>
+            </a:r>
+            <a:br>
+              <a:rPr lang="pt-BR" sz="1400" dirty="0">
+                <a:solidFill>
+                  <a:schemeClr val="bg1"/>
+                </a:solidFill>
+                <a:latin typeface="Consolas"/>
+              </a:rPr>
+            </a:br>
+            <a:br>
+              <a:rPr lang="pt-BR" sz="1400" dirty="0">
+                <a:solidFill>
+                  <a:srgbClr val="4EC9B0"/>
+                </a:solidFill>
+                <a:latin typeface="Consolas"/>
+              </a:rPr>
+            </a:br>
+            <a:r>
+              <a:rPr lang="es-ES" sz="1400" dirty="0">
+                <a:solidFill>
+                  <a:srgbClr val="4EC9B0"/>
+                </a:solidFill>
+                <a:latin typeface="Consolas"/>
+              </a:rPr>
+              <a:t>    &lt;</a:t>
+            </a:r>
+            <a:r>
+              <a:rPr lang="es-ES" sz="1400" dirty="0" err="1">
+                <a:solidFill>
+                  <a:srgbClr val="4EC9B0"/>
+                </a:solidFill>
+                <a:latin typeface="Consolas"/>
+              </a:rPr>
+              <a:t>div</a:t>
+            </a:r>
+            <a:r>
+              <a:rPr lang="es-ES" sz="1400" dirty="0">
+                <a:solidFill>
+                  <a:srgbClr val="4EC9B0"/>
+                </a:solidFill>
+                <a:latin typeface="Consolas"/>
+              </a:rPr>
+              <a:t>&gt;</a:t>
+            </a:r>
+          </a:p>
+          <a:p>
+            <a:r>
+              <a:rPr lang="es-ES" sz="1400" dirty="0">
+                <a:solidFill>
+                  <a:srgbClr val="4EC9B0"/>
+                </a:solidFill>
+                <a:latin typeface="Consolas"/>
+              </a:rPr>
+              <a:t>        &lt;p id="elemento"&gt;</a:t>
+            </a:r>
+          </a:p>
+          <a:p>
+            <a:r>
+              <a:rPr lang="es-ES" sz="1400" dirty="0">
+                <a:solidFill>
+                  <a:srgbClr val="4EC9B0"/>
+                </a:solidFill>
+                <a:latin typeface="Consolas"/>
+              </a:rPr>
+              <a:t>        &lt;/p&gt;</a:t>
+            </a:r>
+          </a:p>
+          <a:p>
+            <a:r>
+              <a:rPr lang="es-ES" sz="1400" dirty="0">
+                <a:solidFill>
+                  <a:srgbClr val="4EC9B0"/>
+                </a:solidFill>
+                <a:latin typeface="Consolas"/>
+              </a:rPr>
+              <a:t>    &lt;/</a:t>
+            </a:r>
+            <a:r>
+              <a:rPr lang="es-ES" sz="1400" dirty="0" err="1">
+                <a:solidFill>
+                  <a:srgbClr val="4EC9B0"/>
+                </a:solidFill>
+                <a:latin typeface="Consolas"/>
+              </a:rPr>
+              <a:t>div</a:t>
+            </a:r>
+            <a:r>
+              <a:rPr lang="es-ES" sz="1400" dirty="0">
+                <a:solidFill>
+                  <a:srgbClr val="4EC9B0"/>
+                </a:solidFill>
+                <a:latin typeface="Consolas"/>
+              </a:rPr>
+              <a:t>&gt;</a:t>
+            </a:r>
+          </a:p>
+          <a:p>
+            <a:pPr>
+              <a:spcAft>
+                <a:spcPts val="1000"/>
+              </a:spcAft>
+              <a:defRPr sz="1500">
+                <a:solidFill>
+                  <a:srgbClr val="F9FAFB"/>
+                </a:solidFill>
+                <a:latin typeface="Arial"/>
+              </a:defRPr>
+            </a:pPr>
+            <a:endParaRPr dirty="0"/>
+          </a:p>
+        </p:txBody>
+      </p:sp>
+      <p:sp>
+        <p:nvSpPr>
+          <p:cNvPr id="4" name="TextBox 3"/>
+          <p:cNvSpPr txBox="1"/>
+          <p:nvPr/>
+        </p:nvSpPr>
+        <p:spPr>
+          <a:xfrm>
+            <a:off x="6309360" y="2011680"/>
+            <a:ext cx="5303520" cy="4114800"/>
+          </a:xfrm>
+          <a:prstGeom prst="rect">
+            <a:avLst/>
+          </a:prstGeom>
+          <a:noFill/>
+        </p:spPr>
+        <p:txBody>
+          <a:bodyPr wrap="square">
+            <a:spAutoFit/>
+          </a:bodyPr>
+          <a:lstStyle/>
+          <a:p>
+            <a:pPr>
+              <a:spcAft>
+                <a:spcPts val="1400"/>
+              </a:spcAft>
+              <a:defRPr sz="2200" b="1">
+                <a:solidFill>
+                  <a:srgbClr val="10B981"/>
+                </a:solidFill>
+                <a:latin typeface="Arial"/>
+              </a:defRPr>
+            </a:pPr>
+            <a:r>
+              <a:t>O próximo passo</a:t>
+            </a:r>
+          </a:p>
+          <a:p>
+            <a:pPr>
+              <a:spcAft>
+                <a:spcPts val="1000"/>
+              </a:spcAft>
+              <a:defRPr sz="1500">
+                <a:solidFill>
+                  <a:srgbClr val="F9FAFB"/>
+                </a:solidFill>
+                <a:latin typeface="Arial"/>
+              </a:defRPr>
+            </a:pPr>
+            <a:r>
+              <a:t>• Manipular tags completas e formatações.</a:t>
+            </a:r>
+          </a:p>
+          <a:p>
+            <a:pPr>
+              <a:spcAft>
+                <a:spcPts val="1000"/>
+              </a:spcAft>
+              <a:defRPr sz="1500">
+                <a:solidFill>
+                  <a:srgbClr val="F9FAFB"/>
+                </a:solidFill>
+                <a:latin typeface="Arial"/>
+              </a:defRPr>
+            </a:pPr>
+            <a:r>
+              <a:t>• Controlar o visual (CSS) em tempo real.</a:t>
+            </a:r>
+          </a:p>
+          <a:p>
+            <a:pPr>
+              <a:spcAft>
+                <a:spcPts val="1000"/>
+              </a:spcAft>
+              <a:defRPr sz="1500">
+                <a:solidFill>
+                  <a:srgbClr val="F9FAFB"/>
+                </a:solidFill>
+                <a:latin typeface="Arial"/>
+              </a:defRPr>
+            </a:pPr>
+            <a:r>
+              <a:t>• Criar componentes inteiros de forma dinâmica.</a:t>
+            </a:r>
+          </a:p>
+          <a:p>
+            <a:pPr>
+              <a:spcAft>
+                <a:spcPts val="1000"/>
+              </a:spcAft>
+              <a:defRPr sz="1500">
+                <a:solidFill>
+                  <a:srgbClr val="F9FAFB"/>
+                </a:solidFill>
+                <a:latin typeface="Arial"/>
+              </a:defRPr>
+            </a:pPr>
+            <a:r>
+              <a:t>• Gerenciar o estado da interface com classes.</a:t>
+            </a:r>
+          </a:p>
+        </p:txBody>
+      </p:sp>
+    </p:spTree>
+  </p:cSld>
+  <p:clrMapOvr>
+    <a:masterClrMapping/>
+  </p:clrMapOvr>
+</p:sld>
+</file>
+
+<file path=ppt/slides/slide9.xml><?xml version="1.0" encoding="utf-8"?>
+<p:sld xmlns:a="http://schemas.openxmlformats.org/drawingml/2006/main" xmlns:r="http://schemas.openxmlformats.org/officeDocument/2006/relationships" xmlns:p="http://schemas.openxmlformats.org/presentationml/2006/main">
+  <p:cSld>
+    <p:spTree>
+      <p:nvGrpSpPr>
+        <p:cNvPr id="1" name=""/>
+        <p:cNvGrpSpPr/>
+        <p:nvPr/>
+      </p:nvGrpSpPr>
+      <p:grpSpPr>
+        <a:xfrm>
+          <a:off x="0" y="0"/>
+          <a:ext cx="0" cy="0"/>
+          <a:chOff x="0" y="0"/>
+          <a:chExt cx="0" cy="0"/>
+        </a:xfrm>
+      </p:grpSpPr>
+      <p:sp>
+        <p:nvSpPr>
+          <p:cNvPr id="2" name="TextBox 1"/>
+          <p:cNvSpPr txBox="1"/>
+          <p:nvPr/>
+        </p:nvSpPr>
+        <p:spPr>
+          <a:xfrm>
+            <a:off x="548640" y="365760"/>
+            <a:ext cx="11094415" cy="1097280"/>
+          </a:xfrm>
+          <a:prstGeom prst="rect">
+            <a:avLst/>
+          </a:prstGeom>
+          <a:noFill/>
+        </p:spPr>
+        <p:txBody>
+          <a:bodyPr wrap="square" lIns="0" tIns="0" rIns="0" bIns="0">
+            <a:spAutoFit/>
+          </a:bodyPr>
+          <a:lstStyle/>
+          <a:p>
+            <a:pPr>
+              <a:spcAft>
+                <a:spcPts val="400"/>
+              </a:spcAft>
+              <a:defRPr sz="3200" b="1">
+                <a:solidFill>
+                  <a:srgbClr val="F9FAFB"/>
+                </a:solidFill>
+                <a:latin typeface="Arial"/>
+              </a:defRPr>
+            </a:pPr>
+            <a:r>
+              <a:t>1. Inserindo Estruturas com innerHTML</a:t>
+            </a:r>
+          </a:p>
+          <a:p>
+            <a:pPr>
+              <a:defRPr sz="1400">
+                <a:solidFill>
+                  <a:srgbClr val="9CA3AF"/>
+                </a:solidFill>
+                <a:latin typeface="Arial"/>
+              </a:defRPr>
+            </a:pPr>
+            <a:r>
+              <a:t>Diferenciando texto puro de marcação interpretada</a:t>
+            </a:r>
+          </a:p>
+        </p:txBody>
+      </p:sp>
+      <p:sp>
+        <p:nvSpPr>
+          <p:cNvPr id="3" name="TextBox 2"/>
+          <p:cNvSpPr txBox="1"/>
+          <p:nvPr/>
+        </p:nvSpPr>
+        <p:spPr>
+          <a:xfrm>
+            <a:off x="548640" y="1828800"/>
+            <a:ext cx="5303520" cy="4389120"/>
+          </a:xfrm>
+          <a:prstGeom prst="rect">
+            <a:avLst/>
+          </a:prstGeom>
+          <a:noFill/>
+        </p:spPr>
+        <p:txBody>
+          <a:bodyPr wrap="square">
+            <a:spAutoFit/>
+          </a:bodyPr>
+          <a:lstStyle/>
+          <a:p>
+            <a:pPr>
+              <a:spcAft>
+                <a:spcPts val="1000"/>
+              </a:spcAft>
+              <a:defRPr sz="1800" b="1">
+                <a:solidFill>
+                  <a:srgbClr val="9CA3AF"/>
+                </a:solidFill>
+                <a:latin typeface="Arial"/>
+              </a:defRPr>
+            </a:pPr>
+            <a:r>
+              <a:rPr dirty="0"/>
+              <a:t>Como </a:t>
+            </a:r>
+            <a:r>
+              <a:rPr dirty="0" err="1"/>
+              <a:t>textContent</a:t>
+            </a:r>
+            <a:r>
+              <a:rPr dirty="0"/>
+              <a:t> </a:t>
+            </a:r>
+            <a:r>
+              <a:rPr dirty="0" err="1"/>
+              <a:t>trata</a:t>
+            </a:r>
+            <a:r>
+              <a:rPr dirty="0"/>
+              <a:t> tags:</a:t>
+            </a:r>
+          </a:p>
+          <a:p>
+            <a:pPr>
+              <a:spcAft>
+                <a:spcPts val="1400"/>
+              </a:spcAft>
+              <a:defRPr sz="1400">
+                <a:solidFill>
+                  <a:srgbClr val="F9FAFB"/>
+                </a:solidFill>
+                <a:latin typeface="Consolas"/>
+              </a:defRPr>
+            </a:pPr>
+            <a:r>
+              <a:rPr dirty="0" err="1"/>
+              <a:t>el.textContent</a:t>
+            </a:r>
+            <a:r>
+              <a:rPr dirty="0"/>
+              <a:t> = '&lt;strong&gt;</a:t>
+            </a:r>
+            <a:r>
+              <a:rPr dirty="0" err="1"/>
+              <a:t>Olá</a:t>
+            </a:r>
+            <a:r>
+              <a:rPr dirty="0"/>
+              <a:t>&lt;/strong&gt;';</a:t>
+            </a:r>
+          </a:p>
+          <a:p>
+            <a:pPr>
+              <a:defRPr sz="1400">
+                <a:solidFill>
+                  <a:srgbClr val="9CA3AF"/>
+                </a:solidFill>
+                <a:latin typeface="Arial"/>
+              </a:defRPr>
+            </a:pPr>
+            <a:r>
+              <a:rPr dirty="0" err="1"/>
+              <a:t>Resultado</a:t>
+            </a:r>
+            <a:r>
+              <a:rPr dirty="0"/>
+              <a:t> </a:t>
+            </a:r>
+            <a:r>
+              <a:rPr dirty="0" err="1"/>
+              <a:t>na</a:t>
+            </a:r>
+            <a:r>
+              <a:rPr dirty="0"/>
+              <a:t> </a:t>
+            </a:r>
+            <a:r>
+              <a:rPr dirty="0" err="1"/>
+              <a:t>tela</a:t>
+            </a:r>
+            <a:r>
+              <a:rPr dirty="0"/>
+              <a:t>:</a:t>
+            </a:r>
+            <a:br>
+              <a:rPr dirty="0"/>
+            </a:br>
+            <a:r>
+              <a:rPr dirty="0"/>
+              <a:t>&lt;strong&gt;</a:t>
+            </a:r>
+            <a:r>
+              <a:rPr dirty="0" err="1"/>
+              <a:t>Olá</a:t>
+            </a:r>
+            <a:r>
+              <a:rPr dirty="0"/>
+              <a:t>&lt;/strong&gt; (</a:t>
+            </a:r>
+            <a:r>
+              <a:rPr dirty="0" err="1"/>
+              <a:t>Texto</a:t>
+            </a:r>
+            <a:r>
+              <a:rPr dirty="0"/>
+              <a:t> literal)</a:t>
+            </a:r>
+          </a:p>
+        </p:txBody>
+      </p:sp>
+      <p:sp>
+        <p:nvSpPr>
+          <p:cNvPr id="4" name="TextBox 3"/>
+          <p:cNvSpPr txBox="1"/>
+          <p:nvPr/>
+        </p:nvSpPr>
+        <p:spPr>
+          <a:xfrm>
+            <a:off x="6309360" y="1828800"/>
+            <a:ext cx="5303520" cy="1980029"/>
+          </a:xfrm>
+          <a:prstGeom prst="rect">
+            <a:avLst/>
+          </a:prstGeom>
+          <a:noFill/>
+        </p:spPr>
+        <p:txBody>
+          <a:bodyPr wrap="square">
+            <a:spAutoFit/>
+          </a:bodyPr>
+          <a:lstStyle/>
+          <a:p>
+            <a:pPr>
+              <a:spcAft>
+                <a:spcPts val="1000"/>
+              </a:spcAft>
+              <a:defRPr sz="1800" b="1">
+                <a:solidFill>
+                  <a:srgbClr val="FBBF24"/>
+                </a:solidFill>
+                <a:latin typeface="Arial"/>
+              </a:defRPr>
+            </a:pPr>
+            <a:r>
+              <a:rPr dirty="0"/>
+              <a:t>Como </a:t>
+            </a:r>
+            <a:r>
+              <a:rPr dirty="0" err="1"/>
+              <a:t>innerHTML</a:t>
+            </a:r>
+            <a:r>
+              <a:rPr dirty="0"/>
+              <a:t> </a:t>
+            </a:r>
+            <a:r>
+              <a:rPr dirty="0" err="1"/>
+              <a:t>trata</a:t>
+            </a:r>
+            <a:r>
+              <a:rPr dirty="0"/>
+              <a:t> tags:</a:t>
+            </a:r>
+          </a:p>
+          <a:p>
+            <a:pPr>
+              <a:spcAft>
+                <a:spcPts val="1400"/>
+              </a:spcAft>
+              <a:defRPr sz="1400">
+                <a:solidFill>
+                  <a:srgbClr val="FBBF24"/>
+                </a:solidFill>
+                <a:latin typeface="Consolas"/>
+              </a:defRPr>
+            </a:pPr>
+            <a:r>
+              <a:rPr dirty="0" err="1"/>
+              <a:t>el.innerHTML</a:t>
+            </a:r>
+            <a:r>
+              <a:rPr dirty="0"/>
+              <a:t> = '&lt;strong&gt;</a:t>
+            </a:r>
+            <a:r>
+              <a:rPr dirty="0" err="1"/>
+              <a:t>Olá</a:t>
+            </a:r>
+            <a:r>
+              <a:rPr dirty="0"/>
+              <a:t>&lt;/strong&gt;';</a:t>
+            </a:r>
+          </a:p>
+          <a:p>
+            <a:pPr>
+              <a:spcAft>
+                <a:spcPts val="2000"/>
+              </a:spcAft>
+              <a:defRPr sz="1400">
+                <a:solidFill>
+                  <a:srgbClr val="F9FAFB"/>
+                </a:solidFill>
+                <a:latin typeface="Arial"/>
+              </a:defRPr>
+            </a:pPr>
+            <a:r>
+              <a:rPr dirty="0" err="1"/>
+              <a:t>Resultado</a:t>
+            </a:r>
+            <a:r>
+              <a:rPr dirty="0"/>
+              <a:t> </a:t>
+            </a:r>
+            <a:r>
+              <a:rPr dirty="0" err="1"/>
+              <a:t>na</a:t>
+            </a:r>
+            <a:r>
+              <a:rPr dirty="0"/>
+              <a:t> </a:t>
+            </a:r>
+            <a:r>
+              <a:rPr dirty="0" err="1"/>
+              <a:t>tela</a:t>
+            </a:r>
+            <a:r>
+              <a:rPr dirty="0"/>
+              <a:t>:</a:t>
+            </a:r>
+            <a:br>
+              <a:rPr dirty="0"/>
+            </a:br>
+            <a:r>
+              <a:rPr dirty="0" err="1"/>
+              <a:t>Olá</a:t>
+            </a:r>
+            <a:r>
+              <a:rPr dirty="0"/>
+              <a:t> (</a:t>
+            </a:r>
+            <a:r>
+              <a:rPr dirty="0" err="1"/>
+              <a:t>Texto</a:t>
+            </a:r>
+            <a:r>
+              <a:rPr dirty="0"/>
+              <a:t> </a:t>
+            </a:r>
+            <a:r>
+              <a:rPr dirty="0" err="1"/>
+              <a:t>em</a:t>
+            </a:r>
+            <a:r>
+              <a:rPr dirty="0"/>
+              <a:t> </a:t>
+            </a:r>
+            <a:r>
+              <a:rPr dirty="0" err="1"/>
+              <a:t>negrito</a:t>
+            </a:r>
+            <a:r>
+              <a:rPr dirty="0"/>
+              <a:t> real)</a:t>
+            </a:r>
+          </a:p>
+          <a:p>
+            <a:pPr>
+              <a:defRPr sz="1300" b="1">
+                <a:solidFill>
+                  <a:srgbClr val="EF4444"/>
+                </a:solidFill>
+                <a:latin typeface="Arial"/>
+              </a:defRPr>
+            </a:pPr>
+            <a:r>
+              <a:rPr dirty="0"/>
+              <a:t>⚠️ ATENÇÃO: </a:t>
+            </a:r>
+            <a:r>
+              <a:rPr dirty="0" err="1"/>
+              <a:t>Nunca</a:t>
+            </a:r>
+            <a:r>
+              <a:rPr dirty="0"/>
+              <a:t> use com dados </a:t>
+            </a:r>
+            <a:r>
+              <a:rPr dirty="0" err="1"/>
+              <a:t>diretos</a:t>
+            </a:r>
+            <a:r>
+              <a:rPr dirty="0"/>
+              <a:t> do </a:t>
+            </a:r>
+            <a:r>
+              <a:rPr dirty="0" err="1"/>
+              <a:t>usuário</a:t>
+            </a:r>
+            <a:r>
+              <a:rPr dirty="0"/>
+              <a:t> (</a:t>
+            </a:r>
+            <a:r>
+              <a:rPr dirty="0" err="1"/>
+              <a:t>Risco</a:t>
+            </a:r>
+            <a:r>
+              <a:rPr dirty="0"/>
+              <a:t> de </a:t>
+            </a:r>
+            <a:r>
+              <a:rPr dirty="0" err="1"/>
+              <a:t>Segurança</a:t>
+            </a:r>
+            <a:r>
+              <a:rPr dirty="0"/>
+              <a:t>).</a:t>
             </a:r>
           </a:p>
         </p:txBody>

</xml_diff>